<commit_message>
Seminarium: uzupelnione przemowienie + nowy watek mszanski
- przemowienie-muzeum-bez-scian.md/.pdf: wersja gotowa do wygloszenia (13 sekcji,
  didaskalia, plan ciecia do 10 min, zrodla) - ~1950 slow / 16 min
- nowy rozdzial: Grob Ofiar Marszu Smierci w Mszanie (33 ofiary, pomnik 1965,
  tablice z 2011 r., tablica wdziecznosci w kosciele sw. Jerzego) + slajd w prezentacji
- uzupelnione fakty: ul. Ofiar Oswiecimskich (pomnik i krzyz), dworzec Rybnicka 2A,
  pierwszy Marsz Pamieci przez Zory 25-26.01.2025, Swierklany (13 ofiar, pomnik 1948),
  start Marszu Pamieci 2012 (Jan Stolarz)
- artykul i podstrona zaktualizowane; generator PDF przemowienia; README

Co-authored-by: arena-agent <297053741+arena-agent@users.noreply.github.com>
</commit_message>
<xml_diff>
--- a/seminarium/prezentacja-muzeum-bez-scian.pptx
+++ b/seminarium/prezentacja-muzeum-bez-scian.pptx
@@ -29,6 +29,7 @@
     <p:sldId id="277" r:id="rId29"/>
     <p:sldId id="278" r:id="rId30"/>
     <p:sldId id="279" r:id="rId31"/>
+    <p:sldId id="280" r:id="rId32"/>
   </p:sldIdLst>
   <p:sldSz cx="12191695" cy="6858000" type="screen4x3"/>
   <p:notesSz cx="6858000" cy="9144000"/>
@@ -610,7 +611,7 @@
           <a:lstStyle/>
           <a:p>
             <a:r>
-              <a:t>Gdy skracamy do 10 minut: wymień tylko dwa z czterech punktów sieci — oszczędność ok. 15 s.</a:t>
+              <a:t>DO POTWIERZENIA: czy województwo nie prowadzi już bonu kultury / dnia z wolnym wstępem. Jeśli tak — podać nazwę programu i budżet.</a:t>
             </a:r>
           </a:p>
         </p:txBody>
@@ -680,17 +681,7 @@
           <a:lstStyle/>
           <a:p>
             <a:r>
-              <a:t>DO UZUPEŁNIENIA: nazwa ulicy, przy której stoją pomnik i krzyż.</a:t>
-            </a:r>
-          </a:p>
-          <a:p>
-            <a:r>
-              <a:t>Mieć pod ręką link do podcastu na Spotify na wypadek pytania z sali.</a:t>
-            </a:r>
-          </a:p>
-          <a:p>
-            <a:r>
-              <a:t>Egzemplarz książki „Kierunek Loslau” do wglądu przy ustalaniu przebiegu ulic.</a:t>
+              <a:t>Gdy skracamy do 10 minut: wymień tylko dwa z czterech punktów sieci — oszczędność ok. 15 s.</a:t>
             </a:r>
           </a:p>
         </p:txBody>
@@ -760,7 +751,17 @@
           <a:lstStyle/>
           <a:p>
             <a:r>
-              <a:t>Gdy skracamy do 10 minut: pomiń akapit o Bawarii, zostaw nazwę i wniosek do Rady Europy — oszczędność ok. 25 s.</a:t>
+              <a:t>Adresy potwierdzone: ul. Michalskiego 4a (tablica), dworzec kolejowy ul. Rybnicka 2A, pomnik i krzyż przy ul. Ofiar Oświęcimskich.</a:t>
+            </a:r>
+          </a:p>
+          <a:p>
+            <a:r>
+              <a:t>Mieć pod ręką link do podcastu na Spotify na wypadek pytania z sali.</a:t>
+            </a:r>
+          </a:p>
+          <a:p>
+            <a:r>
+              <a:t>Egzemplarz książki „Kierunek Loslau” do wglądu przy ustalaniu przebiegu ulic.</a:t>
             </a:r>
           </a:p>
         </p:txBody>
@@ -830,17 +831,7 @@
           <a:lstStyle/>
           <a:p>
             <a:r>
-              <a:t>DO POTWIERDZENIA: czy w Wodzisławiu na pewno nie ma jeszcze kamieni pamięci — zapytać lokalnych historyków lub w urzędzie miasta.</a:t>
-            </a:r>
-          </a:p>
-          <a:p>
-            <a:r>
-              <a:t>Mieć kontakt do fundacji Guntera Demniga (koszt kamienia ok. 120 euro) na wypadek pytania „kto to robi?”.</a:t>
-            </a:r>
-          </a:p>
-          <a:p>
-            <a:r>
-              <a:t>Pytanie o kontrowersje wokół kamieni: pamięć, o którą się dyskutuje, żyje.</a:t>
+              <a:t>Gdy skracamy do 10 minut: pomiń akapit o Bawarii, zostaw nazwę i wniosek do Rady Europy — oszczędność ok. 25 s.</a:t>
             </a:r>
           </a:p>
         </p:txBody>
@@ -910,7 +901,17 @@
           <a:lstStyle/>
           <a:p>
             <a:r>
-              <a:t>Gdy skracamy do 10 minut: jedno zdanie o kamieniach, jedno o drzewach — oszczędność ok. 50 s.</a:t>
+              <a:t>DO POTWIERDZENIA: czy w Wodzisławiu na pewno nie ma jeszcze kamieni pamięci — zapytać lokalnych historyków lub w urzędzie miasta.</a:t>
+            </a:r>
+          </a:p>
+          <a:p>
+            <a:r>
+              <a:t>Mieć kontakt do fundacji Guntera Demniga (koszt kamienia ok. 120 euro) na wypadek pytania „kto to robi?”.</a:t>
+            </a:r>
+          </a:p>
+          <a:p>
+            <a:r>
+              <a:t>Pytanie o kontrowersje wokół kamieni: pamięć, o którą się dyskutuje, żyje.</a:t>
             </a:r>
           </a:p>
         </p:txBody>
@@ -980,7 +981,7 @@
           <a:lstStyle/>
           <a:p>
             <a:r>
-              <a:t>„Bo za dziesięć lat już ich nie będzie” — to zdanie zostawić w ciszy.</a:t>
+              <a:t>Gdy skracamy do 10 minut: jedno zdanie o kamieniach, jedno o drzewach — oszczędność ok. 50 s.</a:t>
             </a:r>
           </a:p>
         </p:txBody>
@@ -1050,7 +1051,7 @@
           <a:lstStyle/>
           <a:p>
             <a:r>
-              <a:t>Slajd „wizualny” — dobrze, jeśli w wersji na rzutnik pojawi się tu zdjęcie lub szkic muralu.</a:t>
+              <a:t>„Bo za dziesięć lat już ich nie będzie” — to zdanie zostawić w ciszy.</a:t>
             </a:r>
           </a:p>
         </p:txBody>
@@ -1120,12 +1121,7 @@
           <a:lstStyle/>
           <a:p>
             <a:r>
-              <a:t>Przykład do opowiedzenia: 30 sekund głosu mieszkanki, której babcia widziała przechodzącą kolumnę.</a:t>
-            </a:r>
-          </a:p>
-          <a:p>
-            <a:r>
-              <a:t>Gdy skracamy do 10 minut: lista do trzech najważniejszych pozycji — oszczędność ok. 30 s.</a:t>
+              <a:t>Slajd „wizualny” — dobrze, jeśli w wersji na rzutnik pojawi się tu zdjęcie lub szkic muralu.</a:t>
             </a:r>
           </a:p>
         </p:txBody>
@@ -1195,7 +1191,12 @@
           <a:lstStyle/>
           <a:p>
             <a:r>
-              <a:t>Kluczowe zdanie do wypowiedzenia w ciszy: „Jeśli nie posadzimy obok siebie dziewięćdziesięciolatka i siedemnastolatki — jednego, który pamięta, i drugiej, która potrafi nagrać i udostępnić — to pewne historie znikną na zawsze.”</a:t>
+              <a:t>Przykład do opowiedzenia: 30 sekund głosu mieszkanki, której babcia widziała przechodzącą kolumnę.</a:t>
+            </a:r>
+          </a:p>
+          <a:p>
+            <a:r>
+              <a:t>Gdy skracamy do 10 minut: lista do trzech najważniejszych pozycji — oszczędność ok. 30 s.</a:t>
             </a:r>
           </a:p>
         </p:txBody>
@@ -1265,7 +1266,7 @@
           <a:lstStyle/>
           <a:p>
             <a:r>
-              <a:t>Zatrzymać się nad tym zdaniem. Pauza. Potem wiersz zamykający (slajd następny).</a:t>
+              <a:t>Kluczowe zdanie do wypowiedzenia w ciszy: „Jeśli nie posadzimy obok siebie dziewięćdziesięciolatka i siedemnastolatki — jednego, który pamięta, i drugiej, która potrafi nagrać i udostępnić — to pewne historie znikną na zawsze.”</a:t>
             </a:r>
           </a:p>
         </p:txBody>
@@ -1410,7 +1411,7 @@
           <a:lstStyle/>
           <a:p>
             <a:r>
-              <a:t>Czytamy wolno, z pauzami między strofami.</a:t>
+              <a:t>Zatrzymać się nad tym zdaniem. Pauza. Potem wiersz zamykający (slajd następny).</a:t>
             </a:r>
           </a:p>
         </p:txBody>
@@ -1480,17 +1481,7 @@
           <a:lstStyle/>
           <a:p>
             <a:r>
-              <a:t>Gdy skracamy do 10 minut: zostaw dwa zdania — oszczędność ok. 40 s.</a:t>
-            </a:r>
-          </a:p>
-          <a:p>
-            <a:r>
-              <a:t>DO SPRAWDZENIA: aktualne terminy naboru (Sendlerowa/CEO, EUSTORY, Geremek) — zmieniają się co rok.</a:t>
-            </a:r>
-          </a:p>
-          <a:p>
-            <a:r>
-              <a:t>Przygotować krótkie uzasadnienie: kto z nauczycieli w powiecie zasługuje na nominację.</a:t>
+              <a:t>Czytamy wolno, z pauzami między strofami.</a:t>
             </a:r>
           </a:p>
         </p:txBody>
@@ -1560,17 +1551,17 @@
           <a:lstStyle/>
           <a:p>
             <a:r>
-              <a:t>Kluczowa pointa: „Taki plan jest już napisany — leży w dokumentach tego projektu. Brakuje podpisów.”</a:t>
-            </a:r>
-          </a:p>
-          <a:p>
-            <a:r>
-              <a:t>Gdy skracamy do 10 minut: pomiń akapit o planie współpracy — oszczędność ok. 30 s.</a:t>
-            </a:r>
-          </a:p>
-          <a:p>
-            <a:r>
-              <a:t>DO USTALENIA: kto podpisuje umowę szkoła–muzeum i kiedy (pierwszy krok planu).</a:t>
+              <a:t>Gdy skracamy do 10 minut: zostaw dwa zdania — oszczędność ok. 40 s.</a:t>
+            </a:r>
+          </a:p>
+          <a:p>
+            <a:r>
+              <a:t>DO SPRAWDZENIA: aktualne terminy naboru (Sendlerowa/CEO, EUSTORY, Geremek) — zmieniają się co rok.</a:t>
+            </a:r>
+          </a:p>
+          <a:p>
+            <a:r>
+              <a:t>Przygotować krótkie uzasadnienie: kto z nauczycieli w powiecie zasługuje na nominację.</a:t>
             </a:r>
           </a:p>
         </p:txBody>
@@ -1640,7 +1631,17 @@
           <a:lstStyle/>
           <a:p>
             <a:r>
-              <a:t>Ostatnie zdanie powiedzieć wolniej i zostać chwilę w ciszy.</a:t>
+              <a:t>Kluczowa pointa: „Taki plan jest już napisany — leży w dokumentach tego projektu. Brakuje podpisów.”</a:t>
+            </a:r>
+          </a:p>
+          <a:p>
+            <a:r>
+              <a:t>Gdy skracamy do 10 minut: pomiń akapit o planie współpracy — oszczędność ok. 30 s.</a:t>
+            </a:r>
+          </a:p>
+          <a:p>
+            <a:r>
+              <a:t>DO USTALENIA: kto podpisuje umowę szkoła–muzeum i kiedy (pierwszy krok planu).</a:t>
             </a:r>
           </a:p>
         </p:txBody>
@@ -1710,6 +1711,76 @@
           <a:lstStyle/>
           <a:p>
             <a:r>
+              <a:t>Ostatnie zdanie powiedzieć wolniej i zostać chwilę w ciszy.</a:t>
+            </a:r>
+          </a:p>
+        </p:txBody>
+      </p:sp>
+      <p:sp>
+        <p:nvSpPr>
+          <p:cNvPr id="4" name="Slide Number Placeholder 3"/>
+          <p:cNvSpPr>
+            <a:spLocks noGrp="1"/>
+          </p:cNvSpPr>
+          <p:nvPr>
+            <p:ph type="sldNum" idx="5" sz="quarter"/>
+          </p:nvPr>
+        </p:nvSpPr>
+        <p:spPr/>
+      </p:sp>
+    </p:spTree>
+  </p:cSld>
+  <p:clrMapOvr>
+    <a:masterClrMapping/>
+  </p:clrMapOvr>
+</p:notes>
+</file>
+
+<file path=ppt/notesSlides/notesSlide25.xml><?xml version="1.0" encoding="utf-8"?>
+<p:notes xmlns:a="http://schemas.openxmlformats.org/drawingml/2006/main" xmlns:p="http://schemas.openxmlformats.org/presentationml/2006/main" xmlns:r="http://schemas.openxmlformats.org/officeDocument/2006/relationships">
+  <p:cSld>
+    <p:spTree>
+      <p:nvGrpSpPr>
+        <p:cNvPr id="1" name=""/>
+        <p:cNvGrpSpPr/>
+        <p:nvPr/>
+      </p:nvGrpSpPr>
+      <p:grpSpPr>
+        <a:xfrm>
+          <a:off x="0" y="0"/>
+          <a:ext cx="0" cy="0"/>
+          <a:chOff x="0" y="0"/>
+          <a:chExt cx="0" cy="0"/>
+        </a:xfrm>
+      </p:grpSpPr>
+      <p:sp>
+        <p:nvSpPr>
+          <p:cNvPr id="2" name="Slide Image Placeholder 1"/>
+          <p:cNvSpPr>
+            <a:spLocks noGrp="1"/>
+          </p:cNvSpPr>
+          <p:nvPr>
+            <p:ph type="sldImg" idx="2"/>
+          </p:nvPr>
+        </p:nvSpPr>
+        <p:spPr/>
+      </p:sp>
+      <p:sp>
+        <p:nvSpPr>
+          <p:cNvPr id="3" name="Notes Placeholder 2"/>
+          <p:cNvSpPr>
+            <a:spLocks noGrp="1"/>
+          </p:cNvSpPr>
+          <p:nvPr>
+            <p:ph type="body" idx="3" sz="quarter"/>
+          </p:nvPr>
+        </p:nvSpPr>
+        <p:spPr/>
+        <p:txBody>
+          <a:bodyPr/>
+          <a:lstStyle/>
+          <a:p>
+            <a:r>
               <a:t>Slajd na wypadek pytań z sali — można go zostawić na końcu prezentacji jako zaplecze źródłowe.</a:t>
             </a:r>
           </a:p>
@@ -2070,7 +2141,7 @@
           </a:p>
           <a:p>
             <a:r>
-              <a:t>DO POTWIERDZENIA przed wygłoszeniem: dokładna data i przebieg pierwszego Marszu Pamięci przez Żory (w tekście: 2025 r.).</a:t>
+              <a:t>Data i trasa potwierdzone: 25–26 stycznia 2025 r. (Pszczyna – Żory – Wodzisław), inicjatywa Tomasza Przybylskiego.</a:t>
             </a:r>
           </a:p>
         </p:txBody>
@@ -2140,7 +2211,7 @@
           <a:lstStyle/>
           <a:p>
             <a:r>
-              <a:t>Tu warto podać przykład z własnego podwórka (wystawa z przedmiotów przyniesionych).</a:t>
+              <a:t>Najmocniejszy akcent lokalny całego wystąpienia — mówimy spokojnie, z pauzami. Po ostatnim zdaniu (na slajdzie) zostawić ciszę.</a:t>
             </a:r>
           </a:p>
         </p:txBody>
@@ -2210,7 +2281,7 @@
           <a:lstStyle/>
           <a:p>
             <a:r>
-              <a:t>DO POTWIERZENIA: czy województwo nie prowadzi już bonu kultury / dnia z wolnym wstępem. Jeśli tak — podać nazwę programu i budżet.</a:t>
+              <a:t>Tu warto podać przykład z własnego podwórka (wystawa z przedmiotów przyniesionych).</a:t>
             </a:r>
           </a:p>
         </p:txBody>
@@ -5350,7 +5421,7 @@
         <p:spPr>
           <a:xfrm>
             <a:off x="640080" y="502920"/>
-            <a:ext cx="2011680" cy="502920"/>
+            <a:ext cx="1828800" cy="502920"/>
           </a:xfrm>
           <a:prstGeom prst="rect">
             <a:avLst/>
@@ -5388,7 +5459,7 @@
                 </a:solidFill>
                 <a:latin typeface="Arial"/>
               </a:rPr>
-              <a:t>6. MUZEUM BEZ ŚCIAN (1)</a:t>
+              <a:t>6. DOSTĘP</a:t>
             </a:r>
           </a:p>
         </p:txBody>
@@ -5427,7 +5498,7 @@
                 </a:solidFill>
                 <a:latin typeface="Arial"/>
               </a:rPr>
-              <a:t>Eko-muzeum, czyli muzeum rozproszone</a:t>
+              <a:t>Kultura jako prawo, nie przywilej</a:t>
             </a:r>
           </a:p>
         </p:txBody>
@@ -5466,7 +5537,7 @@
                 </a:solidFill>
                 <a:latin typeface="Arial"/>
               </a:rPr>
-              <a:t>•  Zamiast jednego budynku — całe miasto i jego okolice jako sieć punktów.</a:t>
+              <a:t>•  Francja, Włochy, Hiszpania: bon kulturowy w aplikacji dla każdego młodego człowieka.</a:t>
             </a:r>
           </a:p>
           <a:p>
@@ -5482,7 +5553,7 @@
                 </a:solidFill>
                 <a:latin typeface="Arial"/>
               </a:rPr>
-              <a:t>•  Wystawa o grodzie słowiańskim w Lubomi.</a:t>
+              <a:t>•  Wielka Brytania: muzea narodowe bezpłatne od 2001 roku.</a:t>
             </a:r>
           </a:p>
           <a:p>
@@ -5498,7 +5569,7 @@
                 </a:solidFill>
                 <a:latin typeface="Arial"/>
               </a:rPr>
-              <a:t>•  Dawny kopiec zamkowy w parku.</a:t>
+              <a:t>•  Propozycja dla województwa: 100 zł raz w roku dla każdego ucznia — do wydania wyłącznie w muzeach regionu.</a:t>
             </a:r>
           </a:p>
           <a:p>
@@ -5514,23 +5585,7 @@
                 </a:solidFill>
                 <a:latin typeface="Arial"/>
               </a:rPr>
-              <a:t>•  Wodzisławski browar.</a:t>
-            </a:r>
-          </a:p>
-          <a:p>
-            <a:pPr algn="l">
-              <a:spcAft>
-                <a:spcPts val="900"/>
-              </a:spcAft>
-            </a:pPr>
-            <a:r>
-              <a:rPr sz="1600" b="0" i="0">
-                <a:solidFill>
-                  <a:srgbClr val="222222"/>
-                </a:solidFill>
-                <a:latin typeface="Arial"/>
-              </a:rPr>
-              <a:t>•  Kościół Świętego Krzyża.</a:t>
+              <a:t>•  Plus comiesięczny dzień z wolnym wstępem dla wszystkich.</a:t>
             </a:r>
           </a:p>
         </p:txBody>
@@ -5569,7 +5624,7 @@
                 </a:solidFill>
                 <a:latin typeface="Arial"/>
               </a:rPr>
-              <a:t>Sztuka może wyjść z sal na ulicę.</a:t>
+              <a:t>Nie namawiamy. Nie przekonujemy. Otwieramy drzwi — i patrzymy, kto wejdzie.</a:t>
             </a:r>
           </a:p>
         </p:txBody>
@@ -5601,7 +5656,7 @@
         <p:spPr>
           <a:xfrm>
             <a:off x="640080" y="502920"/>
-            <a:ext cx="2011680" cy="502920"/>
+            <a:ext cx="2521915" cy="502920"/>
           </a:xfrm>
           <a:prstGeom prst="rect">
             <a:avLst/>
@@ -5639,7 +5694,7 @@
                 </a:solidFill>
                 <a:latin typeface="Arial"/>
               </a:rPr>
-              <a:t>7. MUZEUM BEZ ŚCIAN (2)</a:t>
+              <a:t>7. MUZEUM BEZ ŚCIAN (1)</a:t>
             </a:r>
           </a:p>
         </p:txBody>
@@ -5678,7 +5733,7 @@
                 </a:solidFill>
                 <a:latin typeface="Arial"/>
               </a:rPr>
-              <a:t>Droga Loslau: trasa, którą się przechodzi</a:t>
+              <a:t>Eko-muzeum, czyli muzeum rozproszone</a:t>
             </a:r>
           </a:p>
         </p:txBody>
@@ -5717,7 +5772,7 @@
                 </a:solidFill>
                 <a:latin typeface="Arial"/>
               </a:rPr>
-              <a:t>•  Niewidzialna ścieżka przez Wodzisław: od granic miasta, przez konkretne ulice, aż do dworca.</a:t>
+              <a:t>•  Zamiast jednego budynku — całe miasto i jego okolice jako sieć punktów.</a:t>
             </a:r>
           </a:p>
           <a:p>
@@ -5733,7 +5788,7 @@
                 </a:solidFill>
                 <a:latin typeface="Arial"/>
               </a:rPr>
-              <a:t>•  Dziś trzy punkty: tablica przy ulicy Michalskiego, miejsce pamięci na dworcu, pomnik i krzyż przy ulicy.</a:t>
+              <a:t>•  Wystawa o grodzie słowiańskim w Lubomi.</a:t>
             </a:r>
           </a:p>
           <a:p>
@@ -5749,7 +5804,7 @@
                 </a:solidFill>
                 <a:latin typeface="Arial"/>
               </a:rPr>
-              <a:t>•  Do zbudowania: jedna trasa — audioprzewodnik w głosach mieszkańców, kody QR otwierające archiwalne zdjęcia w miejscu zdarzenia, stacje na 10 minut.</a:t>
+              <a:t>•  Dawny kopiec zamkowy w parku.</a:t>
             </a:r>
           </a:p>
           <a:p>
@@ -5765,7 +5820,23 @@
                 </a:solidFill>
                 <a:latin typeface="Arial"/>
               </a:rPr>
-              <a:t>•  Przebieg trasy odtworzył wodzisławski historyk Piotr Hojka; od 2012 roku idzie nią co stycznia Marsz Pamięci.</a:t>
+              <a:t>•  Wodzisławski browar.</a:t>
+            </a:r>
+          </a:p>
+          <a:p>
+            <a:pPr algn="l">
+              <a:spcAft>
+                <a:spcPts val="900"/>
+              </a:spcAft>
+            </a:pPr>
+            <a:r>
+              <a:rPr sz="1600" b="0" i="0">
+                <a:solidFill>
+                  <a:srgbClr val="222222"/>
+                </a:solidFill>
+                <a:latin typeface="Arial"/>
+              </a:rPr>
+              <a:t>•  Kościół Świętego Krzyża.</a:t>
             </a:r>
           </a:p>
         </p:txBody>
@@ -5804,7 +5875,7 @@
                 </a:solidFill>
                 <a:latin typeface="Arial"/>
               </a:rPr>
-              <a:t>Brakuje jednego — żeby ta droga istniała także wtedy, gdy nikt nią nie idzie.</a:t>
+              <a:t>Sztuka może wyjść z sal na ulicę.</a:t>
             </a:r>
           </a:p>
         </p:txBody>
@@ -5836,7 +5907,7 @@
         <p:spPr>
           <a:xfrm>
             <a:off x="640080" y="502920"/>
-            <a:ext cx="2011680" cy="502920"/>
+            <a:ext cx="2521915" cy="502920"/>
           </a:xfrm>
           <a:prstGeom prst="rect">
             <a:avLst/>
@@ -5874,7 +5945,7 @@
                 </a:solidFill>
                 <a:latin typeface="Arial"/>
               </a:rPr>
-              <a:t>8. WZORZEC</a:t>
+              <a:t>8. MUZEUM BEZ ŚCIAN (2)</a:t>
             </a:r>
           </a:p>
         </p:txBody>
@@ -5913,7 +5984,7 @@
                 </a:solidFill>
                 <a:latin typeface="Arial"/>
               </a:rPr>
-              <a:t>Bawaria: droga, która istnieje zawsze</a:t>
+              <a:t>Droga Loslau: trasa, którą się przechodzi</a:t>
             </a:r>
           </a:p>
         </p:txBody>
@@ -5952,7 +6023,7 @@
                 </a:solidFill>
                 <a:latin typeface="Arial"/>
               </a:rPr>
-              <a:t>•  Wzdłuż trasy marszu z Dachau stanęły 22 identyczne pomniki autorstwa Huberta von Pilgrima (jedna kopia w Yad Vashem w Jerozolimie).</a:t>
+              <a:t>•  Niewidzialna ścieżka przez Wodzisław: od granic miasta, przez konkretne ulice, aż do dworca.</a:t>
             </a:r>
           </a:p>
           <a:p>
@@ -5968,7 +6039,7 @@
                 </a:solidFill>
                 <a:latin typeface="Arial"/>
               </a:rPr>
-              <a:t>•  Dzięki nim droga istnieje, nawet gdy zmieniają się ulice, właściciele i pokolenia.</a:t>
+              <a:t>•  Dziś trzy punkty: tablica przy ul. Michalskiego 4a, tablica na dworcu kolejowym (ul. Rybnicka 2A), pomnik ofiar i krzyż przy ul. Ofiar Oświęcimskich.</a:t>
             </a:r>
           </a:p>
           <a:p>
@@ -5984,7 +6055,7 @@
                 </a:solidFill>
                 <a:latin typeface="Arial"/>
               </a:rPr>
-              <a:t>•  U nas: ten sam znak w Oświęcimiu, Pszczynie, Żorach, Świerklanach, Marklowicach i na wodzisławskim dworcu.</a:t>
+              <a:t>•  Do zbudowania: jedna trasa — audioprzewodnik w głosach mieszkańców, kody QR otwierające archiwalne zdjęcia w miejscu zdarzenia, stacje na 10 minut.</a:t>
             </a:r>
           </a:p>
           <a:p>
@@ -6000,7 +6071,46 @@
                 </a:solidFill>
                 <a:latin typeface="Arial"/>
               </a:rPr>
-              <a:t>•  Wniosek: wpisanie trasy do Szlaku Wyzwolenia Europy — szlaku kulturowego Rady Europy.</a:t>
+              <a:t>•  Przebieg trasy odtworzył wodzisławski historyk Piotr Hojka; od 2012 roku idzie nią co stycznia Marsz Pamięci.</a:t>
+            </a:r>
+          </a:p>
+        </p:txBody>
+      </p:sp>
+      <p:sp>
+        <p:nvSpPr>
+          <p:cNvPr id="5" name="TextBox 4"/>
+          <p:cNvSpPr txBox="1"/>
+          <p:nvPr/>
+        </p:nvSpPr>
+        <p:spPr>
+          <a:xfrm>
+            <a:off x="822960" y="5394960"/>
+            <a:ext cx="10515600" cy="1005840"/>
+          </a:xfrm>
+          <a:prstGeom prst="rect">
+            <a:avLst/>
+          </a:prstGeom>
+          <a:noFill/>
+        </p:spPr>
+        <p:txBody>
+          <a:bodyPr wrap="square">
+            <a:spAutoFit/>
+          </a:bodyPr>
+          <a:lstStyle/>
+          <a:p>
+            <a:pPr algn="l">
+              <a:spcAft>
+                <a:spcPts val="800"/>
+              </a:spcAft>
+            </a:pPr>
+            <a:r>
+              <a:rPr sz="1900" b="1" i="0">
+                <a:solidFill>
+                  <a:srgbClr val="C9821A"/>
+                </a:solidFill>
+                <a:latin typeface="Arial"/>
+              </a:rPr>
+              <a:t>Brakuje jednego — żeby ta droga istniała także wtedy, gdy nikt nią nie idzie.</a:t>
             </a:r>
           </a:p>
         </p:txBody>
@@ -6032,7 +6142,7 @@
         <p:spPr>
           <a:xfrm>
             <a:off x="640080" y="502920"/>
-            <a:ext cx="2011680" cy="502920"/>
+            <a:ext cx="1828800" cy="502920"/>
           </a:xfrm>
           <a:prstGeom prst="rect">
             <a:avLst/>
@@ -6070,7 +6180,7 @@
                 </a:solidFill>
                 <a:latin typeface="Arial"/>
               </a:rPr>
-              <a:t>9. FORMAT MAKSYMALNIE PARTYCYPACYJNY</a:t>
+              <a:t>9. WZORZEC</a:t>
             </a:r>
           </a:p>
         </p:txBody>
@@ -6109,7 +6219,7 @@
                 </a:solidFill>
                 <a:latin typeface="Arial"/>
               </a:rPr>
-              <a:t>Kamienie pamięci</a:t>
+              <a:t>Bawaria: droga, która istnieje zawsze</a:t>
             </a:r>
           </a:p>
         </p:txBody>
@@ -6148,7 +6258,7 @@
                 </a:solidFill>
                 <a:latin typeface="Arial"/>
               </a:rPr>
-              <a:t>•  1992 r., Kolonia: Gunter Demnig wmurowuje pierwszą kostkę z mosiężną tabliczką — imię, data, miejsce śmierci.</a:t>
+              <a:t>•  Wzdłuż trasy marszu z Dachau stanęły 22 identyczne pomniki autorstwa Huberta von Pilgrima (jedna kopia w Yad Vashem w Jerozolimie).</a:t>
             </a:r>
           </a:p>
           <a:p>
@@ -6164,7 +6274,7 @@
                 </a:solidFill>
                 <a:latin typeface="Arial"/>
               </a:rPr>
-              <a:t>•  Dziś: ponad 120 000 kamieni w ponad 30 krajach Europy. W Polsce m.in. we Wrocławiu, Warszawie i Poznaniu.</a:t>
+              <a:t>•  Dzięki nim droga istnieje, nawet gdy zmieniają się ulice, właściciele i pokolenia.</a:t>
             </a:r>
           </a:p>
           <a:p>
@@ -6180,7 +6290,7 @@
                 </a:solidFill>
                 <a:latin typeface="Arial"/>
               </a:rPr>
-              <a:t>•  W Wodzisławiu — jeszcze żadnego.</a:t>
+              <a:t>•  U nas: ten sam znak w Oświęcimiu, Pszczynie, Żorach, Świerklanach, Marklowicach i na wodzisławskim dworcu.</a:t>
             </a:r>
           </a:p>
           <a:p>
@@ -6196,46 +6306,7 @@
                 </a:solidFill>
                 <a:latin typeface="Arial"/>
               </a:rPr>
-              <a:t>•  Kamień fundują mieszkańcy, często klasy szkolne. Jeden człowiek, jeden kamień.</a:t>
-            </a:r>
-          </a:p>
-        </p:txBody>
-      </p:sp>
-      <p:sp>
-        <p:nvSpPr>
-          <p:cNvPr id="5" name="TextBox 4"/>
-          <p:cNvSpPr txBox="1"/>
-          <p:nvPr/>
-        </p:nvSpPr>
-        <p:spPr>
-          <a:xfrm>
-            <a:off x="822960" y="5394960"/>
-            <a:ext cx="10515600" cy="1005840"/>
-          </a:xfrm>
-          <a:prstGeom prst="rect">
-            <a:avLst/>
-          </a:prstGeom>
-          <a:noFill/>
-        </p:spPr>
-        <p:txBody>
-          <a:bodyPr wrap="square">
-            <a:spAutoFit/>
-          </a:bodyPr>
-          <a:lstStyle/>
-          <a:p>
-            <a:pPr algn="l">
-              <a:spcAft>
-                <a:spcPts val="800"/>
-              </a:spcAft>
-            </a:pPr>
-            <a:r>
-              <a:rPr sz="1900" b="1" i="0">
-                <a:solidFill>
-                  <a:srgbClr val="C9821A"/>
-                </a:solidFill>
-                <a:latin typeface="Arial"/>
-              </a:rPr>
-              <a:t>Pamięć nie stoi w gablocie. Leży na chodniku, po którym codziennie przechodzimy.</a:t>
+              <a:t>•  Wniosek: wpisanie trasy do Szlaku Wyzwolenia Europy — szlaku kulturowego Rady Europy.</a:t>
             </a:r>
           </a:p>
         </p:txBody>
@@ -6267,7 +6338,7 @@
         <p:spPr>
           <a:xfrm>
             <a:off x="640080" y="502920"/>
-            <a:ext cx="2011680" cy="502920"/>
+            <a:ext cx="3750868" cy="502920"/>
           </a:xfrm>
           <a:prstGeom prst="rect">
             <a:avLst/>
@@ -6305,7 +6376,7 @@
                 </a:solidFill>
                 <a:latin typeface="Arial"/>
               </a:rPr>
-              <a:t>10. DRUGA STRONA PAMIĘCI</a:t>
+              <a:t>10. FORMAT MAKSYMALNIE PARTYCYPACYJNY</a:t>
             </a:r>
           </a:p>
         </p:txBody>
@@ -6344,7 +6415,7 @@
                 </a:solidFill>
                 <a:latin typeface="Arial"/>
               </a:rPr>
-              <a:t>Ogród Sprawiedliwych</a:t>
+              <a:t>Kamienie pamięci</a:t>
             </a:r>
           </a:p>
         </p:txBody>
@@ -6383,7 +6454,7 @@
                 </a:solidFill>
                 <a:latin typeface="Arial"/>
               </a:rPr>
-              <a:t>•  Pierwszy ogród: Mediolan, 2003 r. Warszawski rośnie od 2014 r. — drzewo dla każdego, kto ratował innych.</a:t>
+              <a:t>•  1992 r., Kolonia: Gunter Demnig wmurowuje pierwszą kostkę z mosiężną tabliczką — imię, data, miejsce śmierci.</a:t>
             </a:r>
           </a:p>
           <a:p>
@@ -6399,7 +6470,39 @@
                 </a:solidFill>
                 <a:latin typeface="Arial"/>
               </a:rPr>
-              <a:t>•  U nas: choćby skwer przy pałacu — drzewa dla tych, którzy w styczniu 1945 roku otwierali drzwi.</a:t>
+              <a:t>•  Dziś: ponad 120 000 kamieni w ponad 30 krajach Europy. W Polsce m.in. we Wrocławiu, Warszawie i Poznaniu.</a:t>
+            </a:r>
+          </a:p>
+          <a:p>
+            <a:pPr algn="l">
+              <a:spcAft>
+                <a:spcPts val="900"/>
+              </a:spcAft>
+            </a:pPr>
+            <a:r>
+              <a:rPr sz="1600" b="0" i="0">
+                <a:solidFill>
+                  <a:srgbClr val="222222"/>
+                </a:solidFill>
+                <a:latin typeface="Arial"/>
+              </a:rPr>
+              <a:t>•  W Wodzisławiu — jeszcze żadnego.</a:t>
+            </a:r>
+          </a:p>
+          <a:p>
+            <a:pPr algn="l">
+              <a:spcAft>
+                <a:spcPts val="900"/>
+              </a:spcAft>
+            </a:pPr>
+            <a:r>
+              <a:rPr sz="1600" b="0" i="0">
+                <a:solidFill>
+                  <a:srgbClr val="222222"/>
+                </a:solidFill>
+                <a:latin typeface="Arial"/>
+              </a:rPr>
+              <a:t>•  Kamień fundują mieszkańcy, często klasy szkolne. Jeden człowiek, jeden kamień.</a:t>
             </a:r>
           </a:p>
         </p:txBody>
@@ -6438,7 +6541,7 @@
                 </a:solidFill>
                 <a:latin typeface="Arial"/>
               </a:rPr>
-              <a:t>Kamienie — dla tych, którzy szli. Drzewa — dla tych, którzy nie odwrócili wzroku.</a:t>
+              <a:t>Pamięć nie stoi w gablocie. Leży na chodniku, po którym codziennie przechodzimy.</a:t>
             </a:r>
           </a:p>
         </p:txBody>
@@ -6470,7 +6573,7 @@
         <p:spPr>
           <a:xfrm>
             <a:off x="640080" y="502920"/>
-            <a:ext cx="2011680" cy="502920"/>
+            <a:ext cx="2609697" cy="502920"/>
           </a:xfrm>
           <a:prstGeom prst="rect">
             <a:avLst/>
@@ -6508,7 +6611,7 @@
                 </a:solidFill>
                 <a:latin typeface="Arial"/>
               </a:rPr>
-              <a:t>11. INSTYTUCJA</a:t>
+              <a:t>11. DRUGA STRONA PAMIĘCI</a:t>
             </a:r>
           </a:p>
         </p:txBody>
@@ -6547,7 +6650,7 @@
                 </a:solidFill>
                 <a:latin typeface="Arial"/>
               </a:rPr>
-              <a:t>Archiwum Pamięci Wodzisławia</a:t>
+              <a:t>Ogród Sprawiedliwych</a:t>
             </a:r>
           </a:p>
         </p:txBody>
@@ -6586,7 +6689,7 @@
                 </a:solidFill>
                 <a:latin typeface="Arial"/>
               </a:rPr>
-              <a:t>•  Każdy mieszkaniec przynosi coś, co ma znaczenie: nagrane wspomnienie, zeskanowaną fotografię, przedmiot z historią.</a:t>
+              <a:t>•  Pierwszy ogród: Mediolan, 2003 r. Warszawski rośnie od 2014 r. — drzewo dla każdego, kto ratował innych.</a:t>
             </a:r>
           </a:p>
           <a:p>
@@ -6602,23 +6705,7 @@
                 </a:solidFill>
                 <a:latin typeface="Arial"/>
               </a:rPr>
-              <a:t>•  Wychodzi z poczuciem, że jego życie stało się częścią historii miasta.</a:t>
-            </a:r>
-          </a:p>
-          <a:p>
-            <a:pPr algn="l">
-              <a:spcAft>
-                <a:spcPts val="900"/>
-              </a:spcAft>
-            </a:pPr>
-            <a:r>
-              <a:rPr sz="1600" b="0" i="0">
-                <a:solidFill>
-                  <a:srgbClr val="222222"/>
-                </a:solidFill>
-                <a:latin typeface="Arial"/>
-              </a:rPr>
-              <a:t>•  Pierwsze zadanie: zebrać notatki, listy, pocztówki i głosy, które jeszcze są.</a:t>
+              <a:t>•  U nas: choćby skwer przy pałacu — drzewa dla tych, którzy w styczniu 1945 roku otwierali drzwi.</a:t>
             </a:r>
           </a:p>
         </p:txBody>
@@ -6657,7 +6744,7 @@
                 </a:solidFill>
                 <a:latin typeface="Arial"/>
               </a:rPr>
-              <a:t>Najcenniejsze eksponaty często nie leżą w magazynach. Leżą w szufladach.</a:t>
+              <a:t>Kamienie — dla tych, którzy szli. Drzewa — dla tych, którzy nie odwrócili wzroku.</a:t>
             </a:r>
           </a:p>
         </p:txBody>
@@ -6689,7 +6776,7 @@
         <p:spPr>
           <a:xfrm>
             <a:off x="640080" y="502920"/>
-            <a:ext cx="2011680" cy="502920"/>
+            <a:ext cx="1828800" cy="502920"/>
           </a:xfrm>
           <a:prstGeom prst="rect">
             <a:avLst/>
@@ -6727,7 +6814,7 @@
                 </a:solidFill>
                 <a:latin typeface="Arial"/>
               </a:rPr>
-              <a:t>12. SZTUKA</a:t>
+              <a:t>12. INSTYTUCJA</a:t>
             </a:r>
           </a:p>
         </p:txBody>
@@ -6766,7 +6853,7 @@
                 </a:solidFill>
                 <a:latin typeface="Arial"/>
               </a:rPr>
-              <a:t>Sztuka w przestrzeni miasta</a:t>
+              <a:t>Archiwum Pamięci Wodzisławia</a:t>
             </a:r>
           </a:p>
         </p:txBody>
@@ -6805,7 +6892,7 @@
                 </a:solidFill>
                 <a:latin typeface="Arial"/>
               </a:rPr>
-              <a:t>•  Mural złożony z archiwalnych zdjęć; ścieżka pamięci łącząca pałac z rynkiem.</a:t>
+              <a:t>•  Każdy mieszkaniec przynosi coś, co ma znaczenie: nagrane wspomnienie, zeskanowaną fotografię, przedmiot z historią.</a:t>
             </a:r>
           </a:p>
           <a:p>
@@ -6821,7 +6908,7 @@
                 </a:solidFill>
                 <a:latin typeface="Arial"/>
               </a:rPr>
-              <a:t>•  Mural nie o Marszu Śmierci jako abstrakcyjnym fakcie — o jednym konkretnym geście:</a:t>
+              <a:t>•  Wychodzi z poczuciem, że jego życie stało się częścią historii miasta.</a:t>
             </a:r>
           </a:p>
           <a:p>
@@ -6831,45 +6918,13 @@
               </a:spcAft>
             </a:pPr>
             <a:r>
-              <a:rPr sz="1500" b="0" i="0">
-                <a:solidFill>
-                  <a:srgbClr val="5A5A5A"/>
-                </a:solidFill>
-                <a:latin typeface="Arial"/>
-              </a:rPr>
-              <a:t>      • ręka podająca kromkę chleba,</a:t>
-            </a:r>
-          </a:p>
-          <a:p>
-            <a:pPr algn="l">
-              <a:spcAft>
-                <a:spcPts val="900"/>
-              </a:spcAft>
-            </a:pPr>
-            <a:r>
-              <a:rPr sz="1500" b="0" i="0">
-                <a:solidFill>
-                  <a:srgbClr val="5A5A5A"/>
-                </a:solidFill>
-                <a:latin typeface="Arial"/>
-              </a:rPr>
-              <a:t>      • otwarte drzwi stodoły,</a:t>
-            </a:r>
-          </a:p>
-          <a:p>
-            <a:pPr algn="l">
-              <a:spcAft>
-                <a:spcPts val="900"/>
-              </a:spcAft>
-            </a:pPr>
-            <a:r>
-              <a:rPr sz="1500" b="0" i="0">
-                <a:solidFill>
-                  <a:srgbClr val="5A5A5A"/>
-                </a:solidFill>
-                <a:latin typeface="Arial"/>
-              </a:rPr>
-              <a:t>      • twarze Sprawiedliwych wśród Narodów Świata z tego regionu.</a:t>
+              <a:rPr sz="1600" b="0" i="0">
+                <a:solidFill>
+                  <a:srgbClr val="222222"/>
+                </a:solidFill>
+                <a:latin typeface="Arial"/>
+              </a:rPr>
+              <a:t>•  Pierwsze zadanie: zebrać notatki, listy, pocztówki i głosy, które jeszcze są.</a:t>
             </a:r>
           </a:p>
         </p:txBody>
@@ -6908,7 +6963,7 @@
                 </a:solidFill>
                 <a:latin typeface="Arial"/>
               </a:rPr>
-              <a:t>Pamięć o złu musi być. Pamięć o dobru — też. I musi być widoczna.</a:t>
+              <a:t>Najcenniejsze eksponaty często nie leżą w magazynach. Leżą w szufladach.</a:t>
             </a:r>
           </a:p>
         </p:txBody>
@@ -6940,7 +6995,7 @@
         <p:spPr>
           <a:xfrm>
             <a:off x="640080" y="502920"/>
-            <a:ext cx="2011680" cy="502920"/>
+            <a:ext cx="1828800" cy="502920"/>
           </a:xfrm>
           <a:prstGeom prst="rect">
             <a:avLst/>
@@ -6978,7 +7033,7 @@
                 </a:solidFill>
                 <a:latin typeface="Arial"/>
               </a:rPr>
-              <a:t>13. TECHNOLOGIE</a:t>
+              <a:t>13. SZTUKA</a:t>
             </a:r>
           </a:p>
         </p:txBody>
@@ -7017,7 +7072,7 @@
                 </a:solidFill>
                 <a:latin typeface="Arial"/>
               </a:rPr>
-              <a:t>Historia w kieszeni</a:t>
+              <a:t>Sztuka w przestrzeni miasta</a:t>
             </a:r>
           </a:p>
         </p:txBody>
@@ -7056,7 +7111,7 @@
                 </a:solidFill>
                 <a:latin typeface="Arial"/>
               </a:rPr>
-              <a:t>•  Aplikacja AR odtwarzająca wygląd pałacu z XVIII wieku i rynek sprzed stu dwudziestu lat.</a:t>
+              <a:t>•  Mural złożony z archiwalnych zdjęć; ścieżka pamięci łącząca pałac z rynkiem.</a:t>
             </a:r>
           </a:p>
           <a:p>
@@ -7072,7 +7127,7 @@
                 </a:solidFill>
                 <a:latin typeface="Arial"/>
               </a:rPr>
-              <a:t>•  Cyfrowa rekonstrukcja wnętrz zniszczonych przed wojną.</a:t>
+              <a:t>•  Mural nie o Marszu Śmierci jako abstrakcyjnym fakcie — o jednym konkretnym geście:</a:t>
             </a:r>
           </a:p>
           <a:p>
@@ -7082,13 +7137,13 @@
               </a:spcAft>
             </a:pPr>
             <a:r>
-              <a:rPr sz="1600" b="0" i="0">
-                <a:solidFill>
-                  <a:srgbClr val="222222"/>
-                </a:solidFill>
-                <a:latin typeface="Arial"/>
-              </a:rPr>
-              <a:t>•  Audioprzewodnik z głosami mieszkańców — nie lektora.</a:t>
+              <a:rPr sz="1500" b="0" i="0">
+                <a:solidFill>
+                  <a:srgbClr val="5A5A5A"/>
+                </a:solidFill>
+                <a:latin typeface="Arial"/>
+              </a:rPr>
+              <a:t>      • ręka podająca kromkę chleba,</a:t>
             </a:r>
           </a:p>
           <a:p>
@@ -7098,13 +7153,29 @@
               </a:spcAft>
             </a:pPr>
             <a:r>
-              <a:rPr sz="1600" b="0" i="0">
-                <a:solidFill>
-                  <a:srgbClr val="222222"/>
-                </a:solidFill>
-                <a:latin typeface="Arial"/>
-              </a:rPr>
-              <a:t>•  Kody QR otwierające wspomnienia; cyfrowe zbiory dostępne dla każdego.</a:t>
+              <a:rPr sz="1500" b="0" i="0">
+                <a:solidFill>
+                  <a:srgbClr val="5A5A5A"/>
+                </a:solidFill>
+                <a:latin typeface="Arial"/>
+              </a:rPr>
+              <a:t>      • otwarte drzwi stodoły,</a:t>
+            </a:r>
+          </a:p>
+          <a:p>
+            <a:pPr algn="l">
+              <a:spcAft>
+                <a:spcPts val="900"/>
+              </a:spcAft>
+            </a:pPr>
+            <a:r>
+              <a:rPr sz="1500" b="0" i="0">
+                <a:solidFill>
+                  <a:srgbClr val="5A5A5A"/>
+                </a:solidFill>
+                <a:latin typeface="Arial"/>
+              </a:rPr>
+              <a:t>      • twarze Sprawiedliwych wśród Narodów Świata z tego regionu.</a:t>
             </a:r>
           </a:p>
         </p:txBody>
@@ -7143,7 +7214,7 @@
                 </a:solidFill>
                 <a:latin typeface="Arial"/>
               </a:rPr>
-              <a:t>Ulica, którą dotąd mijaliśmy obojętnie, zaczyna mówić.</a:t>
+              <a:t>Pamięć o złu musi być. Pamięć o dobru — też. I musi być widoczna.</a:t>
             </a:r>
           </a:p>
         </p:txBody>
@@ -7175,7 +7246,7 @@
         <p:spPr>
           <a:xfrm>
             <a:off x="640080" y="502920"/>
-            <a:ext cx="2011680" cy="502920"/>
+            <a:ext cx="1828800" cy="502920"/>
           </a:xfrm>
           <a:prstGeom prst="rect">
             <a:avLst/>
@@ -7213,7 +7284,7 @@
                 </a:solidFill>
                 <a:latin typeface="Arial"/>
               </a:rPr>
-              <a:t>14. LUDZIE</a:t>
+              <a:t>14. TECHNOLOGIE</a:t>
             </a:r>
           </a:p>
         </p:txBody>
@@ -7252,7 +7323,7 @@
                 </a:solidFill>
                 <a:latin typeface="Arial"/>
               </a:rPr>
-              <a:t>Tandemy pokoleń</a:t>
+              <a:t>Historia w kieszeni</a:t>
             </a:r>
           </a:p>
         </p:txBody>
@@ -7291,7 +7362,7 @@
                 </a:solidFill>
                 <a:latin typeface="Arial"/>
               </a:rPr>
-              <a:t>•  Wolontariusze dziedzictwa; seniorzy jako przewodnicy po własnych wspomnieniach.</a:t>
+              <a:t>•  Aplikacja AR odtwarzająca wygląd pałacu z XVIII wieku i rynek sprzed stu dwudziestu lat.</a:t>
             </a:r>
           </a:p>
           <a:p>
@@ -7307,7 +7378,7 @@
                 </a:solidFill>
                 <a:latin typeface="Arial"/>
               </a:rPr>
-              <a:t>•  Młodzi, którzy potrafią je zapisać i udostępnić.</a:t>
+              <a:t>•  Cyfrowa rekonstrukcja wnętrz zniszczonych przed wojną.</a:t>
             </a:r>
           </a:p>
           <a:p>
@@ -7323,7 +7394,7 @@
                 </a:solidFill>
                 <a:latin typeface="Arial"/>
               </a:rPr>
-              <a:t>•  Żywa biblioteka, w której książką jest człowiek — w tym świadkowie Marszu Śmierci.</a:t>
+              <a:t>•  Audioprzewodnik z głosami mieszkańców — nie lektora.</a:t>
             </a:r>
           </a:p>
           <a:p>
@@ -7339,7 +7410,7 @@
                 </a:solidFill>
                 <a:latin typeface="Arial"/>
               </a:rPr>
-              <a:t>•  Tandemy przy warsztatach rzemiosła; nagrania wideo robione telefonami przez licealistów.</a:t>
+              <a:t>•  Kody QR otwierające wspomnienia; cyfrowe zbiory dostępne dla każdego.</a:t>
             </a:r>
           </a:p>
         </p:txBody>
@@ -7378,7 +7449,7 @@
                 </a:solidFill>
                 <a:latin typeface="Arial"/>
               </a:rPr>
-              <a:t>Mamy pięć lat. Może dziesięć.</a:t>
+              <a:t>Ulica, którą dotąd mijaliśmy obojętnie, zaczyna mówić.</a:t>
             </a:r>
           </a:p>
         </p:txBody>
@@ -7410,7 +7481,7 @@
         <p:spPr>
           <a:xfrm>
             <a:off x="640080" y="502920"/>
-            <a:ext cx="2011680" cy="502920"/>
+            <a:ext cx="1828800" cy="502920"/>
           </a:xfrm>
           <a:prstGeom prst="rect">
             <a:avLst/>
@@ -7448,7 +7519,7 @@
                 </a:solidFill>
                 <a:latin typeface="Arial"/>
               </a:rPr>
-              <a:t>15. POWRÓT DO PUNKTU WYJŚCIA</a:t>
+              <a:t>15. LUDZIE</a:t>
             </a:r>
           </a:p>
         </p:txBody>
@@ -7461,8 +7532,8 @@
         </p:nvSpPr>
         <p:spPr>
           <a:xfrm>
-            <a:off x="914400" y="2286000"/>
-            <a:ext cx="10332720" cy="2743200"/>
+            <a:off x="822960" y="1234440"/>
+            <a:ext cx="10515600" cy="822960"/>
           </a:xfrm>
           <a:prstGeom prst="rect">
             <a:avLst/>
@@ -7477,19 +7548,129 @@
           <a:p>
             <a:pPr algn="l">
               <a:spcAft>
-                <a:spcPts val="1800"/>
-              </a:spcAft>
-            </a:pPr>
-            <a:r>
-              <a:rPr sz="4000" b="1" i="0">
+                <a:spcPts val="800"/>
+              </a:spcAft>
+            </a:pPr>
+            <a:r>
+              <a:rPr sz="3000" b="1" i="0">
                 <a:solidFill>
                   <a:srgbClr val="0F5132"/>
                 </a:solidFill>
                 <a:latin typeface="Arial"/>
               </a:rPr>
-              <a:t>Ten pałac powstał z miłości.</a:t>
-            </a:r>
-          </a:p>
+              <a:t>Tandemy pokoleń</a:t>
+            </a:r>
+          </a:p>
+        </p:txBody>
+      </p:sp>
+      <p:sp>
+        <p:nvSpPr>
+          <p:cNvPr id="4" name="TextBox 3"/>
+          <p:cNvSpPr txBox="1"/>
+          <p:nvPr/>
+        </p:nvSpPr>
+        <p:spPr>
+          <a:xfrm>
+            <a:off x="822960" y="2240280"/>
+            <a:ext cx="10515600" cy="3017520"/>
+          </a:xfrm>
+          <a:prstGeom prst="rect">
+            <a:avLst/>
+          </a:prstGeom>
+          <a:noFill/>
+        </p:spPr>
+        <p:txBody>
+          <a:bodyPr wrap="square">
+            <a:spAutoFit/>
+          </a:bodyPr>
+          <a:lstStyle/>
+          <a:p>
+            <a:pPr algn="l">
+              <a:spcAft>
+                <a:spcPts val="900"/>
+              </a:spcAft>
+            </a:pPr>
+            <a:r>
+              <a:rPr sz="1600" b="0" i="0">
+                <a:solidFill>
+                  <a:srgbClr val="222222"/>
+                </a:solidFill>
+                <a:latin typeface="Arial"/>
+              </a:rPr>
+              <a:t>•  Wolontariusze dziedzictwa; seniorzy jako przewodnicy po własnych wspomnieniach.</a:t>
+            </a:r>
+          </a:p>
+          <a:p>
+            <a:pPr algn="l">
+              <a:spcAft>
+                <a:spcPts val="900"/>
+              </a:spcAft>
+            </a:pPr>
+            <a:r>
+              <a:rPr sz="1600" b="0" i="0">
+                <a:solidFill>
+                  <a:srgbClr val="222222"/>
+                </a:solidFill>
+                <a:latin typeface="Arial"/>
+              </a:rPr>
+              <a:t>•  Młodzi, którzy potrafią je zapisać i udostępnić.</a:t>
+            </a:r>
+          </a:p>
+          <a:p>
+            <a:pPr algn="l">
+              <a:spcAft>
+                <a:spcPts val="900"/>
+              </a:spcAft>
+            </a:pPr>
+            <a:r>
+              <a:rPr sz="1600" b="0" i="0">
+                <a:solidFill>
+                  <a:srgbClr val="222222"/>
+                </a:solidFill>
+                <a:latin typeface="Arial"/>
+              </a:rPr>
+              <a:t>•  Żywa biblioteka, w której książką jest człowiek — w tym świadkowie Marszu Śmierci.</a:t>
+            </a:r>
+          </a:p>
+          <a:p>
+            <a:pPr algn="l">
+              <a:spcAft>
+                <a:spcPts val="900"/>
+              </a:spcAft>
+            </a:pPr>
+            <a:r>
+              <a:rPr sz="1600" b="0" i="0">
+                <a:solidFill>
+                  <a:srgbClr val="222222"/>
+                </a:solidFill>
+                <a:latin typeface="Arial"/>
+              </a:rPr>
+              <a:t>•  Tandemy przy warsztatach rzemiosła; nagrania wideo robione telefonami przez licealistów.</a:t>
+            </a:r>
+          </a:p>
+        </p:txBody>
+      </p:sp>
+      <p:sp>
+        <p:nvSpPr>
+          <p:cNvPr id="5" name="TextBox 4"/>
+          <p:cNvSpPr txBox="1"/>
+          <p:nvPr/>
+        </p:nvSpPr>
+        <p:spPr>
+          <a:xfrm>
+            <a:off x="822960" y="5394960"/>
+            <a:ext cx="10515600" cy="1005840"/>
+          </a:xfrm>
+          <a:prstGeom prst="rect">
+            <a:avLst/>
+          </a:prstGeom>
+          <a:noFill/>
+        </p:spPr>
+        <p:txBody>
+          <a:bodyPr wrap="square">
+            <a:spAutoFit/>
+          </a:bodyPr>
+          <a:lstStyle/>
           <a:p>
             <a:pPr algn="l">
               <a:spcAft>
@@ -7497,33 +7678,13 @@
               </a:spcAft>
             </a:pPr>
             <a:r>
-              <a:rPr sz="2000" b="0" i="0">
-                <a:solidFill>
-                  <a:srgbClr val="5A5A5A"/>
-                </a:solidFill>
-                <a:latin typeface="Arial"/>
-              </a:rPr>
-              <a:t>A w styczniu 1945 roku, tuż obok, przechodziła kolumna,</a:t>
-            </a:r>
-            <a:br/>
-            <a:r>
-              <a:rPr sz="2000" b="0" i="0">
-                <a:solidFill>
-                  <a:srgbClr val="5A5A5A"/>
-                </a:solidFill>
-                <a:latin typeface="Arial"/>
-              </a:rPr>
-              <a:t>w której każdy kolejny krok był przeciwieństwem miłości.</a:t>
-            </a:r>
-            <a:br/>
-            <a:r>
-              <a:rPr sz="2000" b="0" i="0">
-                <a:solidFill>
-                  <a:srgbClr val="5A5A5A"/>
-                </a:solidFill>
-                <a:latin typeface="Arial"/>
-              </a:rPr>
-              <a:t>Nie żeby jedno zasłaniało drugie — żeby jedno drugie oświetlało.</a:t>
+              <a:rPr sz="1900" b="1" i="0">
+                <a:solidFill>
+                  <a:srgbClr val="C9821A"/>
+                </a:solidFill>
+                <a:latin typeface="Arial"/>
+              </a:rPr>
+              <a:t>Mamy pięć lat. Może dziesięć.</a:t>
             </a:r>
           </a:p>
         </p:txBody>
@@ -7692,221 +7853,6 @@
       <p:grpSpPr/>
       <p:sp>
         <p:nvSpPr>
-          <p:cNvPr id="2" name="TextBox 1"/>
-          <p:cNvSpPr txBox="1"/>
-          <p:nvPr/>
-        </p:nvSpPr>
-        <p:spPr>
-          <a:xfrm>
-            <a:off x="1463040" y="2103120"/>
-            <a:ext cx="9235440" cy="3840480"/>
-          </a:xfrm>
-          <a:prstGeom prst="rect">
-            <a:avLst/>
-          </a:prstGeom>
-          <a:noFill/>
-        </p:spPr>
-        <p:txBody>
-          <a:bodyPr wrap="square">
-            <a:spAutoFit/>
-          </a:bodyPr>
-          <a:lstStyle/>
-          <a:p>
-            <a:pPr algn="l">
-              <a:spcAft>
-                <a:spcPts val="600"/>
-              </a:spcAft>
-            </a:pPr>
-            <a:r>
-              <a:rPr sz="2200" b="0" i="0">
-                <a:solidFill>
-                  <a:srgbClr val="222222"/>
-                </a:solidFill>
-                <a:latin typeface="Arial"/>
-              </a:rPr>
-              <a:t>Nie każda historia mieści się w gablocie.</a:t>
-            </a:r>
-          </a:p>
-          <a:p>
-            <a:pPr algn="l">
-              <a:spcAft>
-                <a:spcPts val="600"/>
-              </a:spcAft>
-            </a:pPr>
-            <a:r>
-              <a:rPr sz="2200" b="0" i="0">
-                <a:solidFill>
-                  <a:srgbClr val="222222"/>
-                </a:solidFill>
-                <a:latin typeface="Arial"/>
-              </a:rPr>
-              <a:t>Czasem śpi w szufladzie — w liście, fotografii,</a:t>
-            </a:r>
-          </a:p>
-          <a:p>
-            <a:pPr algn="l">
-              <a:spcAft>
-                <a:spcPts val="600"/>
-              </a:spcAft>
-            </a:pPr>
-            <a:r>
-              <a:rPr sz="2200" b="0" i="0">
-                <a:solidFill>
-                  <a:srgbClr val="222222"/>
-                </a:solidFill>
-                <a:latin typeface="Arial"/>
-              </a:rPr>
-              <a:t>czasem budzi się w głosie starszej pani,</a:t>
-            </a:r>
-          </a:p>
-          <a:p>
-            <a:pPr algn="l">
-              <a:spcAft>
-                <a:spcPts val="600"/>
-              </a:spcAft>
-            </a:pPr>
-            <a:r>
-              <a:rPr sz="2200" b="0" i="0">
-                <a:solidFill>
-                  <a:srgbClr val="222222"/>
-                </a:solidFill>
-                <a:latin typeface="Arial"/>
-              </a:rPr>
-              <a:t>w jednym zdaniu, które drży od wspomnień.</a:t>
-            </a:r>
-          </a:p>
-          <a:p>
-            <a:pPr algn="l">
-              <a:spcAft>
-                <a:spcPts val="600"/>
-              </a:spcAft>
-            </a:pPr>
-          </a:p>
-          <a:p>
-            <a:pPr algn="l">
-              <a:spcAft>
-                <a:spcPts val="600"/>
-              </a:spcAft>
-            </a:pPr>
-            <a:r>
-              <a:rPr sz="2200" b="0" i="0">
-                <a:solidFill>
-                  <a:srgbClr val="222222"/>
-                </a:solidFill>
-                <a:latin typeface="Arial"/>
-              </a:rPr>
-              <a:t>Miasto może stać się salą muzealną,</a:t>
-            </a:r>
-          </a:p>
-          <a:p>
-            <a:pPr algn="l">
-              <a:spcAft>
-                <a:spcPts val="600"/>
-              </a:spcAft>
-            </a:pPr>
-            <a:r>
-              <a:rPr sz="2200" b="0" i="0">
-                <a:solidFill>
-                  <a:srgbClr val="222222"/>
-                </a:solidFill>
-                <a:latin typeface="Arial"/>
-              </a:rPr>
-              <a:t>ulica — ścieżką, dworzec — opowieścią.</a:t>
-            </a:r>
-          </a:p>
-          <a:p>
-            <a:pPr algn="l">
-              <a:spcAft>
-                <a:spcPts val="600"/>
-              </a:spcAft>
-            </a:pPr>
-            <a:r>
-              <a:rPr sz="2200" b="0" i="0">
-                <a:solidFill>
-                  <a:srgbClr val="222222"/>
-                </a:solidFill>
-                <a:latin typeface="Arial"/>
-              </a:rPr>
-              <a:t>Mieszkańcy przyniosą swoje historie,</a:t>
-            </a:r>
-          </a:p>
-          <a:p>
-            <a:pPr algn="l">
-              <a:spcAft>
-                <a:spcPts val="600"/>
-              </a:spcAft>
-            </a:pPr>
-            <a:r>
-              <a:rPr sz="2200" b="0" i="0">
-                <a:solidFill>
-                  <a:srgbClr val="222222"/>
-                </a:solidFill>
-                <a:latin typeface="Arial"/>
-              </a:rPr>
-              <a:t>a młodzi pomogą im nie zamilknąć.</a:t>
-            </a:r>
-          </a:p>
-          <a:p>
-            <a:pPr algn="l">
-              <a:spcAft>
-                <a:spcPts val="600"/>
-              </a:spcAft>
-            </a:pPr>
-          </a:p>
-          <a:p>
-            <a:pPr algn="l">
-              <a:spcAft>
-                <a:spcPts val="600"/>
-              </a:spcAft>
-            </a:pPr>
-            <a:r>
-              <a:rPr sz="2200" b="0" i="0">
-                <a:solidFill>
-                  <a:srgbClr val="222222"/>
-                </a:solidFill>
-                <a:latin typeface="Arial"/>
-              </a:rPr>
-              <a:t>Wtedy muzeum nie oddziela od życia.</a:t>
-            </a:r>
-          </a:p>
-          <a:p>
-            <a:pPr algn="l">
-              <a:spcAft>
-                <a:spcPts val="600"/>
-              </a:spcAft>
-            </a:pPr>
-            <a:r>
-              <a:rPr sz="2200" b="0" i="0">
-                <a:solidFill>
-                  <a:srgbClr val="222222"/>
-                </a:solidFill>
-                <a:latin typeface="Arial"/>
-              </a:rPr>
-              <a:t>Idzie obok, słucha, podaje głos.</a:t>
-            </a:r>
-          </a:p>
-        </p:txBody>
-      </p:sp>
-    </p:spTree>
-  </p:cSld>
-  <p:clrMapOvr>
-    <a:masterClrMapping/>
-  </p:clrMapOvr>
-</p:sld>
-</file>
-
-<file path=ppt/slides/slide21.xml><?xml version="1.0" encoding="utf-8"?>
-<p:sld xmlns:a="http://schemas.openxmlformats.org/drawingml/2006/main" xmlns:p="http://schemas.openxmlformats.org/presentationml/2006/main" xmlns:r="http://schemas.openxmlformats.org/officeDocument/2006/relationships">
-  <p:cSld>
-    <p:spTree>
-      <p:nvGrpSpPr>
-        <p:cNvPr id="1" name=""/>
-        <p:cNvGrpSpPr/>
-        <p:nvPr/>
-      </p:nvGrpSpPr>
-      <p:grpSpPr/>
-      <p:sp>
-        <p:nvSpPr>
           <p:cNvPr id="2" name="Rectangle 1"/>
           <p:cNvSpPr/>
           <p:nvPr/>
@@ -7914,7 +7860,7 @@
         <p:spPr>
           <a:xfrm>
             <a:off x="640080" y="502920"/>
-            <a:ext cx="2011680" cy="502920"/>
+            <a:ext cx="2960827" cy="502920"/>
           </a:xfrm>
           <a:prstGeom prst="rect">
             <a:avLst/>
@@ -7952,7 +7898,7 @@
                 </a:solidFill>
                 <a:latin typeface="Arial"/>
               </a:rPr>
-              <a:t>16. NAUCZYCIELE</a:t>
+              <a:t>16. POWRÓT DO PUNKTU WYJŚCIA</a:t>
             </a:r>
           </a:p>
         </p:txBody>
@@ -7965,8 +7911,8 @@
         </p:nvSpPr>
         <p:spPr>
           <a:xfrm>
-            <a:off x="822960" y="1234440"/>
-            <a:ext cx="10515600" cy="822960"/>
+            <a:off x="914400" y="2286000"/>
+            <a:ext cx="10332720" cy="2743200"/>
           </a:xfrm>
           <a:prstGeom prst="rect">
             <a:avLst/>
@@ -7981,31 +7927,85 @@
           <a:p>
             <a:pPr algn="l">
               <a:spcAft>
+                <a:spcPts val="1800"/>
+              </a:spcAft>
+            </a:pPr>
+            <a:r>
+              <a:rPr sz="4000" b="1" i="0">
+                <a:solidFill>
+                  <a:srgbClr val="0F5132"/>
+                </a:solidFill>
+                <a:latin typeface="Arial"/>
+              </a:rPr>
+              <a:t>Ten pałac powstał z miłości.</a:t>
+            </a:r>
+          </a:p>
+          <a:p>
+            <a:pPr algn="l">
+              <a:spcAft>
                 <a:spcPts val="800"/>
               </a:spcAft>
             </a:pPr>
             <a:r>
-              <a:rPr sz="3000" b="1" i="0">
-                <a:solidFill>
-                  <a:srgbClr val="0F5132"/>
-                </a:solidFill>
-                <a:latin typeface="Arial"/>
-              </a:rPr>
-              <a:t>Nauczyciel doceniony nie odpuszcza</a:t>
-            </a:r>
-          </a:p>
-        </p:txBody>
-      </p:sp>
-      <p:sp>
-        <p:nvSpPr>
-          <p:cNvPr id="4" name="TextBox 3"/>
+              <a:rPr sz="2000" b="0" i="0">
+                <a:solidFill>
+                  <a:srgbClr val="5A5A5A"/>
+                </a:solidFill>
+                <a:latin typeface="Arial"/>
+              </a:rPr>
+              <a:t>A w styczniu 1945 roku, tuż obok, przechodziła kolumna,</a:t>
+            </a:r>
+            <a:br/>
+            <a:r>
+              <a:rPr sz="2000" b="0" i="0">
+                <a:solidFill>
+                  <a:srgbClr val="5A5A5A"/>
+                </a:solidFill>
+                <a:latin typeface="Arial"/>
+              </a:rPr>
+              <a:t>w której każdy kolejny krok był przeciwieństwem miłości.</a:t>
+            </a:r>
+            <a:br/>
+            <a:r>
+              <a:rPr sz="2000" b="0" i="0">
+                <a:solidFill>
+                  <a:srgbClr val="5A5A5A"/>
+                </a:solidFill>
+                <a:latin typeface="Arial"/>
+              </a:rPr>
+              <a:t>Nie żeby jedno zasłaniało drugie — żeby jedno drugie oświetlało.</a:t>
+            </a:r>
+          </a:p>
+        </p:txBody>
+      </p:sp>
+    </p:spTree>
+  </p:cSld>
+  <p:clrMapOvr>
+    <a:masterClrMapping/>
+  </p:clrMapOvr>
+</p:sld>
+</file>
+
+<file path=ppt/slides/slide21.xml><?xml version="1.0" encoding="utf-8"?>
+<p:sld xmlns:a="http://schemas.openxmlformats.org/drawingml/2006/main" xmlns:p="http://schemas.openxmlformats.org/presentationml/2006/main" xmlns:r="http://schemas.openxmlformats.org/officeDocument/2006/relationships">
+  <p:cSld>
+    <p:spTree>
+      <p:nvGrpSpPr>
+        <p:cNvPr id="1" name=""/>
+        <p:cNvGrpSpPr/>
+        <p:nvPr/>
+      </p:nvGrpSpPr>
+      <p:grpSpPr/>
+      <p:sp>
+        <p:nvSpPr>
+          <p:cNvPr id="2" name="TextBox 1"/>
           <p:cNvSpPr txBox="1"/>
           <p:nvPr/>
         </p:nvSpPr>
         <p:spPr>
           <a:xfrm>
-            <a:off x="822960" y="2240280"/>
-            <a:ext cx="10515600" cy="3017520"/>
+            <a:off x="1463040" y="2103120"/>
+            <a:ext cx="9235440" cy="3840480"/>
           </a:xfrm>
           <a:prstGeom prst="rect">
             <a:avLst/>
@@ -8020,65 +8020,175 @@
           <a:p>
             <a:pPr algn="l">
               <a:spcAft>
-                <a:spcPts val="900"/>
-              </a:spcAft>
-            </a:pPr>
-            <a:r>
-              <a:rPr sz="1600" b="0" i="0">
+                <a:spcPts val="600"/>
+              </a:spcAft>
+            </a:pPr>
+            <a:r>
+              <a:rPr sz="2200" b="0" i="0">
                 <a:solidFill>
                   <a:srgbClr val="222222"/>
                 </a:solidFill>
                 <a:latin typeface="Arial"/>
               </a:rPr>
-              <a:t>•  Nagroda im. Ireny Sendlerowej „Za naprawianie świata” (od 2006 r.) — dla nauczycieli uczących tolerancji i szacunku; nagroda pieniężna dla laureata.</a:t>
-            </a:r>
-          </a:p>
-          <a:p>
-            <a:pPr algn="l">
-              <a:spcAft>
-                <a:spcPts val="900"/>
-              </a:spcAft>
-            </a:pPr>
-            <a:r>
-              <a:rPr sz="1600" b="0" i="0">
+              <a:t>Nie każda historia mieści się w gablocie.</a:t>
+            </a:r>
+          </a:p>
+          <a:p>
+            <a:pPr algn="l">
+              <a:spcAft>
+                <a:spcPts val="600"/>
+              </a:spcAft>
+            </a:pPr>
+            <a:r>
+              <a:rPr sz="2200" b="0" i="0">
                 <a:solidFill>
                   <a:srgbClr val="222222"/>
                 </a:solidFill>
                 <a:latin typeface="Arial"/>
               </a:rPr>
-              <a:t>•  EUSTORY — sieć konkursów historycznych (Körber-Stiftung, ponad 20 krajów, ponad 300 tys. uczestników).</a:t>
-            </a:r>
-          </a:p>
-          <a:p>
-            <a:pPr algn="l">
-              <a:spcAft>
-                <a:spcPts val="900"/>
-              </a:spcAft>
-            </a:pPr>
-            <a:r>
-              <a:rPr sz="1600" b="0" i="0">
+              <a:t>Czasem śpi w szufladzie — w liście, fotografii,</a:t>
+            </a:r>
+          </a:p>
+          <a:p>
+            <a:pPr algn="l">
+              <a:spcAft>
+                <a:spcPts val="600"/>
+              </a:spcAft>
+            </a:pPr>
+            <a:r>
+              <a:rPr sz="2200" b="0" i="0">
                 <a:solidFill>
                   <a:srgbClr val="222222"/>
                 </a:solidFill>
                 <a:latin typeface="Arial"/>
               </a:rPr>
-              <a:t>•  Polskie ogniwa: „Historia Bliska” (KARTA, od 1996 r.) i „Moje życie w PRL” (Fundacja Geremka) — wywiad wideo 7–8 min z bliską osobą, wsparcie mentora, nagrody także dla nauczycieli-opiekunów.</a:t>
-            </a:r>
-          </a:p>
-          <a:p>
-            <a:pPr algn="l">
-              <a:spcAft>
-                <a:spcPts val="900"/>
-              </a:spcAft>
-            </a:pPr>
-            <a:r>
-              <a:rPr sz="1600" b="0" i="0">
+              <a:t>czasem budzi się w głosie starszej pani,</a:t>
+            </a:r>
+          </a:p>
+          <a:p>
+            <a:pPr algn="l">
+              <a:spcAft>
+                <a:spcPts val="600"/>
+              </a:spcAft>
+            </a:pPr>
+            <a:r>
+              <a:rPr sz="2200" b="0" i="0">
                 <a:solidFill>
                   <a:srgbClr val="222222"/>
                 </a:solidFill>
                 <a:latin typeface="Arial"/>
               </a:rPr>
-              <a:t>•  W kalendarzu szkoły: Nauczyciel Roku oraz Nauczyciel Jutr@ (z Fundacją Orange).</a:t>
+              <a:t>w jednym zdaniu, które drży od wspomnień.</a:t>
+            </a:r>
+          </a:p>
+          <a:p>
+            <a:pPr algn="l">
+              <a:spcAft>
+                <a:spcPts val="600"/>
+              </a:spcAft>
+            </a:pPr>
+          </a:p>
+          <a:p>
+            <a:pPr algn="l">
+              <a:spcAft>
+                <a:spcPts val="600"/>
+              </a:spcAft>
+            </a:pPr>
+            <a:r>
+              <a:rPr sz="2200" b="0" i="0">
+                <a:solidFill>
+                  <a:srgbClr val="222222"/>
+                </a:solidFill>
+                <a:latin typeface="Arial"/>
+              </a:rPr>
+              <a:t>Miasto może stać się salą muzealną,</a:t>
+            </a:r>
+          </a:p>
+          <a:p>
+            <a:pPr algn="l">
+              <a:spcAft>
+                <a:spcPts val="600"/>
+              </a:spcAft>
+            </a:pPr>
+            <a:r>
+              <a:rPr sz="2200" b="0" i="0">
+                <a:solidFill>
+                  <a:srgbClr val="222222"/>
+                </a:solidFill>
+                <a:latin typeface="Arial"/>
+              </a:rPr>
+              <a:t>ulica — ścieżką, dworzec — opowieścią.</a:t>
+            </a:r>
+          </a:p>
+          <a:p>
+            <a:pPr algn="l">
+              <a:spcAft>
+                <a:spcPts val="600"/>
+              </a:spcAft>
+            </a:pPr>
+            <a:r>
+              <a:rPr sz="2200" b="0" i="0">
+                <a:solidFill>
+                  <a:srgbClr val="222222"/>
+                </a:solidFill>
+                <a:latin typeface="Arial"/>
+              </a:rPr>
+              <a:t>Mieszkańcy przyniosą swoje historie,</a:t>
+            </a:r>
+          </a:p>
+          <a:p>
+            <a:pPr algn="l">
+              <a:spcAft>
+                <a:spcPts val="600"/>
+              </a:spcAft>
+            </a:pPr>
+            <a:r>
+              <a:rPr sz="2200" b="0" i="0">
+                <a:solidFill>
+                  <a:srgbClr val="222222"/>
+                </a:solidFill>
+                <a:latin typeface="Arial"/>
+              </a:rPr>
+              <a:t>a młodzi pomogą im nie zamilknąć.</a:t>
+            </a:r>
+          </a:p>
+          <a:p>
+            <a:pPr algn="l">
+              <a:spcAft>
+                <a:spcPts val="600"/>
+              </a:spcAft>
+            </a:pPr>
+          </a:p>
+          <a:p>
+            <a:pPr algn="l">
+              <a:spcAft>
+                <a:spcPts val="600"/>
+              </a:spcAft>
+            </a:pPr>
+            <a:r>
+              <a:rPr sz="2200" b="0" i="0">
+                <a:solidFill>
+                  <a:srgbClr val="222222"/>
+                </a:solidFill>
+                <a:latin typeface="Arial"/>
+              </a:rPr>
+              <a:t>Wtedy muzeum nie oddziela od życia.</a:t>
+            </a:r>
+          </a:p>
+          <a:p>
+            <a:pPr algn="l">
+              <a:spcAft>
+                <a:spcPts val="600"/>
+              </a:spcAft>
+            </a:pPr>
+            <a:r>
+              <a:rPr sz="2200" b="0" i="0">
+                <a:solidFill>
+                  <a:srgbClr val="222222"/>
+                </a:solidFill>
+                <a:latin typeface="Arial"/>
+              </a:rPr>
+              <a:t>Idzie obok, słucha, podaje głos.</a:t>
             </a:r>
           </a:p>
         </p:txBody>
@@ -8110,7 +8220,7 @@
         <p:spPr>
           <a:xfrm>
             <a:off x="640080" y="502920"/>
-            <a:ext cx="2011680" cy="502920"/>
+            <a:ext cx="1828800" cy="502920"/>
           </a:xfrm>
           <a:prstGeom prst="rect">
             <a:avLst/>
@@ -8148,7 +8258,7 @@
                 </a:solidFill>
                 <a:latin typeface="Arial"/>
               </a:rPr>
-              <a:t>17. PLAN</a:t>
+              <a:t>17. NAUCZYCIELE</a:t>
             </a:r>
           </a:p>
         </p:txBody>
@@ -8187,7 +8297,7 @@
                 </a:solidFill>
                 <a:latin typeface="Arial"/>
               </a:rPr>
-              <a:t>Pięć kroków</a:t>
+              <a:t>Nauczyciel doceniony nie odpuszcza</a:t>
             </a:r>
           </a:p>
         </p:txBody>
@@ -8226,7 +8336,7 @@
                 </a:solidFill>
                 <a:latin typeface="Arial"/>
               </a:rPr>
-              <a:t>•  1. Zapisać wspomnienia. Dopóki jeszcze są.</a:t>
+              <a:t>•  Nagroda im. Ireny Sendlerowej „Za naprawianie świata” (od 2006 r.) — dla nauczycieli uczących tolerancji i szacunku; nagroda pieniężna dla laureata.</a:t>
             </a:r>
           </a:p>
           <a:p>
@@ -8242,7 +8352,7 @@
                 </a:solidFill>
                 <a:latin typeface="Arial"/>
               </a:rPr>
-              <a:t>•  2. Współdecydować z mieszkańcami. Nie konsultować — współdecydować.</a:t>
+              <a:t>•  EUSTORY — sieć konkursów historycznych (Körber-Stiftung, ponad 20 krajów, ponad 300 tys. uczestników).</a:t>
             </a:r>
           </a:p>
           <a:p>
@@ -8258,7 +8368,7 @@
                 </a:solidFill>
                 <a:latin typeface="Arial"/>
               </a:rPr>
-              <a:t>•  3. Udostępnić zbiory cyfrowo. Dziedzictwo zamknięte w magazynie nie istnieje.</a:t>
+              <a:t>•  Polskie ogniwa: „Historia Bliska” (KARTA, od 1996 r.) i „Moje życie w PRL” (Fundacja Geremka) — wywiad wideo 7–8 min z bliską osobą, wsparcie mentora, nagrody także dla nauczycieli-opiekunów.</a:t>
             </a:r>
           </a:p>
           <a:p>
@@ -8274,62 +8384,7 @@
                 </a:solidFill>
                 <a:latin typeface="Arial"/>
               </a:rPr>
-              <a:t>•  4. Wyjść ze sztuką w miasto. Na ulicę Ofiar Oświęcimskich. Na dworzec. Na trasę marszu.</a:t>
-            </a:r>
-          </a:p>
-          <a:p>
-            <a:pPr algn="l">
-              <a:spcAft>
-                <a:spcPts val="900"/>
-              </a:spcAft>
-            </a:pPr>
-            <a:r>
-              <a:rPr sz="1600" b="0" i="0">
-                <a:solidFill>
-                  <a:srgbClr val="222222"/>
-                </a:solidFill>
-                <a:latin typeface="Arial"/>
-              </a:rPr>
-              <a:t>•  5. Włączyć wszystkie pokolenia.</a:t>
-            </a:r>
-          </a:p>
-        </p:txBody>
-      </p:sp>
-      <p:sp>
-        <p:nvSpPr>
-          <p:cNvPr id="5" name="TextBox 4"/>
-          <p:cNvSpPr txBox="1"/>
-          <p:nvPr/>
-        </p:nvSpPr>
-        <p:spPr>
-          <a:xfrm>
-            <a:off x="822960" y="5394960"/>
-            <a:ext cx="10515600" cy="1005840"/>
-          </a:xfrm>
-          <a:prstGeom prst="rect">
-            <a:avLst/>
-          </a:prstGeom>
-          <a:noFill/>
-        </p:spPr>
-        <p:txBody>
-          <a:bodyPr wrap="square">
-            <a:spAutoFit/>
-          </a:bodyPr>
-          <a:lstStyle/>
-          <a:p>
-            <a:pPr algn="l">
-              <a:spcAft>
-                <a:spcPts val="800"/>
-              </a:spcAft>
-            </a:pPr>
-            <a:r>
-              <a:rPr sz="1900" b="1" i="0">
-                <a:solidFill>
-                  <a:srgbClr val="C9821A"/>
-                </a:solidFill>
-                <a:latin typeface="Arial"/>
-              </a:rPr>
-              <a:t>Umowa szkoła–muzeum i kalendarz w rytmie rocznic: nagrania jesienią, marsz w styczniu, wystawa w maju.</a:t>
+              <a:t>•  W kalendarzu szkoły: Nauczyciel Roku oraz Nauczyciel Jutr@ (z Fundacją Orange).</a:t>
             </a:r>
           </a:p>
         </p:txBody>
@@ -8361,7 +8416,7 @@
         <p:spPr>
           <a:xfrm>
             <a:off x="640080" y="502920"/>
-            <a:ext cx="2011680" cy="502920"/>
+            <a:ext cx="1828800" cy="502920"/>
           </a:xfrm>
           <a:prstGeom prst="rect">
             <a:avLst/>
@@ -8399,7 +8454,7 @@
                 </a:solidFill>
                 <a:latin typeface="Arial"/>
               </a:rPr>
-              <a:t>ZAKOŃCZENIE</a:t>
+              <a:t>18. PLAN</a:t>
             </a:r>
           </a:p>
         </p:txBody>
@@ -8412,8 +8467,8 @@
         </p:nvSpPr>
         <p:spPr>
           <a:xfrm>
-            <a:off x="914400" y="2286000"/>
-            <a:ext cx="10332720" cy="2743200"/>
+            <a:off x="822960" y="1234440"/>
+            <a:ext cx="10515600" cy="822960"/>
           </a:xfrm>
           <a:prstGeom prst="rect">
             <a:avLst/>
@@ -8428,29 +8483,145 @@
           <a:p>
             <a:pPr algn="l">
               <a:spcAft>
-                <a:spcPts val="1800"/>
-              </a:spcAft>
-            </a:pPr>
-            <a:r>
-              <a:rPr sz="4000" b="1" i="0">
+                <a:spcPts val="800"/>
+              </a:spcAft>
+            </a:pPr>
+            <a:r>
+              <a:rPr sz="3000" b="1" i="0">
                 <a:solidFill>
                   <a:srgbClr val="0F5132"/>
                 </a:solidFill>
                 <a:latin typeface="Arial"/>
               </a:rPr>
-              <a:t>Niech ten pałac nadal będzie</a:t>
-            </a:r>
-            <a:br/>
-            <a:r>
-              <a:rPr sz="4000" b="1" i="0">
-                <a:solidFill>
-                  <a:srgbClr val="0F5132"/>
-                </a:solidFill>
-                <a:latin typeface="Arial"/>
-              </a:rPr>
-              <a:t>miejscem relacji.</a:t>
-            </a:r>
-          </a:p>
+              <a:t>Pięć kroków</a:t>
+            </a:r>
+          </a:p>
+        </p:txBody>
+      </p:sp>
+      <p:sp>
+        <p:nvSpPr>
+          <p:cNvPr id="4" name="TextBox 3"/>
+          <p:cNvSpPr txBox="1"/>
+          <p:nvPr/>
+        </p:nvSpPr>
+        <p:spPr>
+          <a:xfrm>
+            <a:off x="822960" y="2240280"/>
+            <a:ext cx="10515600" cy="3017520"/>
+          </a:xfrm>
+          <a:prstGeom prst="rect">
+            <a:avLst/>
+          </a:prstGeom>
+          <a:noFill/>
+        </p:spPr>
+        <p:txBody>
+          <a:bodyPr wrap="square">
+            <a:spAutoFit/>
+          </a:bodyPr>
+          <a:lstStyle/>
+          <a:p>
+            <a:pPr algn="l">
+              <a:spcAft>
+                <a:spcPts val="900"/>
+              </a:spcAft>
+            </a:pPr>
+            <a:r>
+              <a:rPr sz="1600" b="0" i="0">
+                <a:solidFill>
+                  <a:srgbClr val="222222"/>
+                </a:solidFill>
+                <a:latin typeface="Arial"/>
+              </a:rPr>
+              <a:t>•  1. Zapisać wspomnienia. Dopóki jeszcze są.</a:t>
+            </a:r>
+          </a:p>
+          <a:p>
+            <a:pPr algn="l">
+              <a:spcAft>
+                <a:spcPts val="900"/>
+              </a:spcAft>
+            </a:pPr>
+            <a:r>
+              <a:rPr sz="1600" b="0" i="0">
+                <a:solidFill>
+                  <a:srgbClr val="222222"/>
+                </a:solidFill>
+                <a:latin typeface="Arial"/>
+              </a:rPr>
+              <a:t>•  2. Współdecydować z mieszkańcami. Nie konsultować — współdecydować.</a:t>
+            </a:r>
+          </a:p>
+          <a:p>
+            <a:pPr algn="l">
+              <a:spcAft>
+                <a:spcPts val="900"/>
+              </a:spcAft>
+            </a:pPr>
+            <a:r>
+              <a:rPr sz="1600" b="0" i="0">
+                <a:solidFill>
+                  <a:srgbClr val="222222"/>
+                </a:solidFill>
+                <a:latin typeface="Arial"/>
+              </a:rPr>
+              <a:t>•  3. Udostępnić zbiory cyfrowo. Dziedzictwo zamknięte w magazynie nie istnieje.</a:t>
+            </a:r>
+          </a:p>
+          <a:p>
+            <a:pPr algn="l">
+              <a:spcAft>
+                <a:spcPts val="900"/>
+              </a:spcAft>
+            </a:pPr>
+            <a:r>
+              <a:rPr sz="1600" b="0" i="0">
+                <a:solidFill>
+                  <a:srgbClr val="222222"/>
+                </a:solidFill>
+                <a:latin typeface="Arial"/>
+              </a:rPr>
+              <a:t>•  4. Wyjść ze sztuką w miasto. Na ulicę Ofiar Oświęcimskich. Na dworzec. Na trasę marszu.</a:t>
+            </a:r>
+          </a:p>
+          <a:p>
+            <a:pPr algn="l">
+              <a:spcAft>
+                <a:spcPts val="900"/>
+              </a:spcAft>
+            </a:pPr>
+            <a:r>
+              <a:rPr sz="1600" b="0" i="0">
+                <a:solidFill>
+                  <a:srgbClr val="222222"/>
+                </a:solidFill>
+                <a:latin typeface="Arial"/>
+              </a:rPr>
+              <a:t>•  5. Włączyć wszystkie pokolenia.</a:t>
+            </a:r>
+          </a:p>
+        </p:txBody>
+      </p:sp>
+      <p:sp>
+        <p:nvSpPr>
+          <p:cNvPr id="5" name="TextBox 4"/>
+          <p:cNvSpPr txBox="1"/>
+          <p:nvPr/>
+        </p:nvSpPr>
+        <p:spPr>
+          <a:xfrm>
+            <a:off x="822960" y="5394960"/>
+            <a:ext cx="10515600" cy="1005840"/>
+          </a:xfrm>
+          <a:prstGeom prst="rect">
+            <a:avLst/>
+          </a:prstGeom>
+          <a:noFill/>
+        </p:spPr>
+        <p:txBody>
+          <a:bodyPr wrap="square">
+            <a:spAutoFit/>
+          </a:bodyPr>
+          <a:lstStyle/>
           <a:p>
             <a:pPr algn="l">
               <a:spcAft>
@@ -8458,13 +8629,13 @@
               </a:spcAft>
             </a:pPr>
             <a:r>
-              <a:rPr sz="2000" b="0" i="0">
-                <a:solidFill>
-                  <a:srgbClr val="5A5A5A"/>
-                </a:solidFill>
-                <a:latin typeface="Arial"/>
-              </a:rPr>
-              <a:t>Dziękuję.</a:t>
+              <a:rPr sz="1900" b="1" i="0">
+                <a:solidFill>
+                  <a:srgbClr val="C9821A"/>
+                </a:solidFill>
+                <a:latin typeface="Arial"/>
+              </a:rPr>
+              <a:t>Umowa szkoła–muzeum i kalendarz w rytmie rocznic: nagrania jesienią, marsz w styczniu, wystawa w maju.</a:t>
             </a:r>
           </a:p>
         </p:txBody>
@@ -8489,6 +8660,141 @@
       <p:grpSpPr/>
       <p:sp>
         <p:nvSpPr>
+          <p:cNvPr id="2" name="Rectangle 1"/>
+          <p:cNvSpPr/>
+          <p:nvPr/>
+        </p:nvSpPr>
+        <p:spPr>
+          <a:xfrm>
+            <a:off x="640080" y="502920"/>
+            <a:ext cx="1828800" cy="502920"/>
+          </a:xfrm>
+          <a:prstGeom prst="rect">
+            <a:avLst/>
+          </a:prstGeom>
+          <a:solidFill>
+            <a:srgbClr val="0F5132"/>
+          </a:solidFill>
+          <a:ln>
+            <a:noFill/>
+          </a:ln>
+        </p:spPr>
+        <p:style>
+          <a:lnRef idx="1">
+            <a:schemeClr val="accent1"/>
+          </a:lnRef>
+          <a:fillRef idx="3">
+            <a:schemeClr val="accent1"/>
+          </a:fillRef>
+          <a:effectRef idx="2">
+            <a:schemeClr val="accent1"/>
+          </a:effectRef>
+          <a:fontRef idx="minor">
+            <a:schemeClr val="lt1"/>
+          </a:fontRef>
+        </p:style>
+        <p:txBody>
+          <a:bodyPr rtlCol="0" anchor="ctr" wrap="none"/>
+          <a:lstStyle/>
+          <a:p>
+            <a:pPr algn="ctr"/>
+            <a:r>
+              <a:rPr sz="1300" b="1">
+                <a:solidFill>
+                  <a:srgbClr val="FFFFFF"/>
+                </a:solidFill>
+                <a:latin typeface="Arial"/>
+              </a:rPr>
+              <a:t>ZAKOŃCZENIE</a:t>
+            </a:r>
+          </a:p>
+        </p:txBody>
+      </p:sp>
+      <p:sp>
+        <p:nvSpPr>
+          <p:cNvPr id="3" name="TextBox 2"/>
+          <p:cNvSpPr txBox="1"/>
+          <p:nvPr/>
+        </p:nvSpPr>
+        <p:spPr>
+          <a:xfrm>
+            <a:off x="914400" y="2286000"/>
+            <a:ext cx="10332720" cy="2743200"/>
+          </a:xfrm>
+          <a:prstGeom prst="rect">
+            <a:avLst/>
+          </a:prstGeom>
+          <a:noFill/>
+        </p:spPr>
+        <p:txBody>
+          <a:bodyPr wrap="square">
+            <a:spAutoFit/>
+          </a:bodyPr>
+          <a:lstStyle/>
+          <a:p>
+            <a:pPr algn="l">
+              <a:spcAft>
+                <a:spcPts val="1800"/>
+              </a:spcAft>
+            </a:pPr>
+            <a:r>
+              <a:rPr sz="4000" b="1" i="0">
+                <a:solidFill>
+                  <a:srgbClr val="0F5132"/>
+                </a:solidFill>
+                <a:latin typeface="Arial"/>
+              </a:rPr>
+              <a:t>Niech ten pałac nadal będzie</a:t>
+            </a:r>
+            <a:br/>
+            <a:r>
+              <a:rPr sz="4000" b="1" i="0">
+                <a:solidFill>
+                  <a:srgbClr val="0F5132"/>
+                </a:solidFill>
+                <a:latin typeface="Arial"/>
+              </a:rPr>
+              <a:t>miejscem relacji.</a:t>
+            </a:r>
+          </a:p>
+          <a:p>
+            <a:pPr algn="l">
+              <a:spcAft>
+                <a:spcPts val="800"/>
+              </a:spcAft>
+            </a:pPr>
+            <a:r>
+              <a:rPr sz="2000" b="0" i="0">
+                <a:solidFill>
+                  <a:srgbClr val="5A5A5A"/>
+                </a:solidFill>
+                <a:latin typeface="Arial"/>
+              </a:rPr>
+              <a:t>Dziękuję.</a:t>
+            </a:r>
+          </a:p>
+        </p:txBody>
+      </p:sp>
+    </p:spTree>
+  </p:cSld>
+  <p:clrMapOvr>
+    <a:masterClrMapping/>
+  </p:clrMapOvr>
+</p:sld>
+</file>
+
+<file path=ppt/slides/slide25.xml><?xml version="1.0" encoding="utf-8"?>
+<p:sld xmlns:a="http://schemas.openxmlformats.org/drawingml/2006/main" xmlns:p="http://schemas.openxmlformats.org/presentationml/2006/main" xmlns:r="http://schemas.openxmlformats.org/officeDocument/2006/relationships">
+  <p:cSld>
+    <p:spTree>
+      <p:nvGrpSpPr>
+        <p:cNvPr id="1" name=""/>
+        <p:cNvGrpSpPr/>
+        <p:nvPr/>
+      </p:nvGrpSpPr>
+      <p:grpSpPr/>
+      <p:sp>
+        <p:nvSpPr>
           <p:cNvPr id="2" name="TextBox 1"/>
           <p:cNvSpPr txBox="1"/>
           <p:nvPr/>
@@ -8704,7 +9010,7 @@
         <p:spPr>
           <a:xfrm>
             <a:off x="640080" y="502920"/>
-            <a:ext cx="2011680" cy="502920"/>
+            <a:ext cx="3487521" cy="502920"/>
           </a:xfrm>
           <a:prstGeom prst="rect">
             <a:avLst/>
@@ -8932,7 +9238,7 @@
         <p:spPr>
           <a:xfrm>
             <a:off x="640080" y="502920"/>
-            <a:ext cx="2011680" cy="502920"/>
+            <a:ext cx="1828800" cy="502920"/>
           </a:xfrm>
           <a:prstGeom prst="rect">
             <a:avLst/>
@@ -9077,7 +9383,7 @@
         <p:spPr>
           <a:xfrm>
             <a:off x="640080" y="502920"/>
-            <a:ext cx="2011680" cy="502920"/>
+            <a:ext cx="1907438" cy="502920"/>
           </a:xfrm>
           <a:prstGeom prst="rect">
             <a:avLst/>
@@ -9296,7 +9602,7 @@
         <p:spPr>
           <a:xfrm>
             <a:off x="640080" y="502920"/>
-            <a:ext cx="2011680" cy="502920"/>
+            <a:ext cx="2083003" cy="502920"/>
           </a:xfrm>
           <a:prstGeom prst="rect">
             <a:avLst/>
@@ -9334,7 +9640,7 @@
                 </a:solidFill>
                 <a:latin typeface="Arial"/>
               </a:rPr>
-              <a:t>2. TEORIA, KTÓRA ZMIENIŁA PRAKTYKĘ</a:t>
+              <a:t>2. NOWA MUZEOLOGIA</a:t>
             </a:r>
           </a:p>
         </p:txBody>
@@ -9476,7 +9782,7 @@
         <p:spPr>
           <a:xfrm>
             <a:off x="640080" y="502920"/>
-            <a:ext cx="2011680" cy="502920"/>
+            <a:ext cx="1995220" cy="502920"/>
           </a:xfrm>
           <a:prstGeom prst="rect">
             <a:avLst/>
@@ -9592,7 +9898,7 @@
                 </a:solidFill>
                 <a:latin typeface="Arial"/>
               </a:rPr>
-              <a:t>•  Podczas pierwszego Marszu Pamięci, który przeszedł trasą przez Żory (2025), wyszła przed dom starsza pani.</a:t>
+              <a:t>•  25–26 stycznia 2025 r., pierwszy Marsz Pamięci trasą Pszczyna – Żory – Wodzisław (inicjatywa Tomasza Przybylskiego). Podczas przejścia przez Świerklany wyszła przed dom starsza pani.</a:t>
             </a:r>
           </a:p>
           <a:p>
@@ -9609,6 +9915,22 @@
                 <a:latin typeface="Arial"/>
               </a:rPr>
               <a:t>•  Ze łzami w oczach: „Miałam siedem lat wtedy i wszystko widziałam — tych więźniów to było straszne, wszystko widziałam…”.</a:t>
+            </a:r>
+          </a:p>
+          <a:p>
+            <a:pPr algn="l">
+              <a:spcAft>
+                <a:spcPts val="900"/>
+              </a:spcAft>
+            </a:pPr>
+            <a:r>
+              <a:rPr sz="1600" b="0" i="0">
+                <a:solidFill>
+                  <a:srgbClr val="222222"/>
+                </a:solidFill>
+                <a:latin typeface="Arial"/>
+              </a:rPr>
+              <a:t>•  W Świerklanach przy cmentarzu parafialnym leży 13 więźniów zamordowanych 18 stycznia 1945 r.; mieszkańcy pochowali ich i w 1948 r. ufundowali pomnik.</a:t>
             </a:r>
           </a:p>
           <a:p>
@@ -9695,7 +10017,7 @@
         <p:spPr>
           <a:xfrm>
             <a:off x="640080" y="502920"/>
-            <a:ext cx="2011680" cy="502920"/>
+            <a:ext cx="2960827" cy="502920"/>
           </a:xfrm>
           <a:prstGeom prst="rect">
             <a:avLst/>
@@ -9733,7 +10055,7 @@
                 </a:solidFill>
                 <a:latin typeface="Arial"/>
               </a:rPr>
-              <a:t>4. PRAKTYKA</a:t>
+              <a:t>5. MIEJSCE, KTÓRE JEST NASZE</a:t>
             </a:r>
           </a:p>
         </p:txBody>
@@ -9772,7 +10094,7 @@
                 </a:solidFill>
                 <a:latin typeface="Arial"/>
               </a:rPr>
-              <a:t>Z odbiorców — we współgospodarzy</a:t>
+              <a:t>Mszana — nasza mogiła, nasza pamięć</a:t>
             </a:r>
           </a:p>
         </p:txBody>
@@ -9811,7 +10133,7 @@
                 </a:solidFill>
                 <a:latin typeface="Arial"/>
               </a:rPr>
-              <a:t>•  Sztuka partycypacyjna i site-specific to dziś stała praktyka wystawiennicza.</a:t>
+              <a:t>•  Na cmentarzu parafialnym przy kościele św. Jerzego: Grób Ofiar Marszu Śmierci — 33 ofiary, ciała złożyli mieszkańcy Mszany.</a:t>
             </a:r>
           </a:p>
           <a:p>
@@ -9827,7 +10149,7 @@
                 </a:solidFill>
                 <a:latin typeface="Arial"/>
               </a:rPr>
-              <a:t>•  Wystawy powstają wspólnie z mieszkańcami — przez konsultacje i wspólne wybieranie tematów.</a:t>
+              <a:t>•  1965 r.: społeczeństwo z własnych funduszy ufundowało pomnik nad bezimienną mogiłą.</a:t>
             </a:r>
           </a:p>
           <a:p>
@@ -9843,7 +10165,7 @@
                 </a:solidFill>
                 <a:latin typeface="Arial"/>
               </a:rPr>
-              <a:t>•  Przykład: doroczna wystawa budowana z przedmiotów i historii przynoszonych przez mieszkańców.</a:t>
+              <a:t>•  2011 r.: archiwiści Yad Vashem i Muzeum Auschwitz-Birkenau ustalili po numerach obozowych nazwiska czworga ofiar; odsłonięto nowe tablice, przyjechała 30-osobowa delegacja z Izraela.</a:t>
             </a:r>
           </a:p>
           <a:p>
@@ -9859,7 +10181,46 @@
                 </a:solidFill>
                 <a:latin typeface="Arial"/>
               </a:rPr>
-              <a:t>•  Muzeum nie musi zgadywać, co interesuje mieszkańców — może ich po prostu zapytać.</a:t>
+              <a:t>•  W przedsionku kościoła tablica wdzięczności dla mieszkańców Mszany, którzy w styczniu 1945 r. ratowali innych. Od 2011 r. grób jest stałym punktem wycieczek z Izraela.</a:t>
+            </a:r>
+          </a:p>
+        </p:txBody>
+      </p:sp>
+      <p:sp>
+        <p:nvSpPr>
+          <p:cNvPr id="5" name="TextBox 4"/>
+          <p:cNvSpPr txBox="1"/>
+          <p:nvPr/>
+        </p:nvSpPr>
+        <p:spPr>
+          <a:xfrm>
+            <a:off x="822960" y="5394960"/>
+            <a:ext cx="10515600" cy="1005840"/>
+          </a:xfrm>
+          <a:prstGeom prst="rect">
+            <a:avLst/>
+          </a:prstGeom>
+          <a:noFill/>
+        </p:spPr>
+        <p:txBody>
+          <a:bodyPr wrap="square">
+            <a:spAutoFit/>
+          </a:bodyPr>
+          <a:lstStyle/>
+          <a:p>
+            <a:pPr algn="l">
+              <a:spcAft>
+                <a:spcPts val="800"/>
+              </a:spcAft>
+            </a:pPr>
+            <a:r>
+              <a:rPr sz="1900" b="1" i="0">
+                <a:solidFill>
+                  <a:srgbClr val="C9821A"/>
+                </a:solidFill>
+                <a:latin typeface="Arial"/>
+              </a:rPr>
+              <a:t>Pamięć nie jest abstrakcją. Pamięć ma adres: cmentarz przy św. Jerzym w Mszanie.</a:t>
             </a:r>
           </a:p>
         </p:txBody>
@@ -9891,7 +10252,7 @@
         <p:spPr>
           <a:xfrm>
             <a:off x="640080" y="502920"/>
-            <a:ext cx="2011680" cy="502920"/>
+            <a:ext cx="1828800" cy="502920"/>
           </a:xfrm>
           <a:prstGeom prst="rect">
             <a:avLst/>
@@ -9929,7 +10290,7 @@
                 </a:solidFill>
                 <a:latin typeface="Arial"/>
               </a:rPr>
-              <a:t>5. DOSTĘP</a:t>
+              <a:t>5. PRAKTYKA</a:t>
             </a:r>
           </a:p>
         </p:txBody>
@@ -9968,7 +10329,7 @@
                 </a:solidFill>
                 <a:latin typeface="Arial"/>
               </a:rPr>
-              <a:t>Kultura jako prawo, nie przywilej</a:t>
+              <a:t>Z odbiorców — we współgospodarzy</a:t>
             </a:r>
           </a:p>
         </p:txBody>
@@ -10007,7 +10368,7 @@
                 </a:solidFill>
                 <a:latin typeface="Arial"/>
               </a:rPr>
-              <a:t>•  Francja, Włochy, Hiszpania: bon kulturowy w aplikacji dla każdego młodego człowieka.</a:t>
+              <a:t>•  Sztuka partycypacyjna i site-specific to dziś stała praktyka wystawiennicza.</a:t>
             </a:r>
           </a:p>
           <a:p>
@@ -10023,7 +10384,7 @@
                 </a:solidFill>
                 <a:latin typeface="Arial"/>
               </a:rPr>
-              <a:t>•  Wielka Brytania: muzea narodowe bezpłatne od 2001 roku.</a:t>
+              <a:t>•  Wystawy powstają wspólnie z mieszkańcami — przez konsultacje i wspólne wybieranie tematów.</a:t>
             </a:r>
           </a:p>
           <a:p>
@@ -10039,7 +10400,7 @@
                 </a:solidFill>
                 <a:latin typeface="Arial"/>
               </a:rPr>
-              <a:t>•  Propozycja dla województwa: 100 zł raz w roku dla każdego ucznia — do wydania wyłącznie w muzeach regionu.</a:t>
+              <a:t>•  Przykład: doroczna wystawa budowana z przedmiotów i historii przynoszonych przez mieszkańców.</a:t>
             </a:r>
           </a:p>
           <a:p>
@@ -10055,46 +10416,7 @@
                 </a:solidFill>
                 <a:latin typeface="Arial"/>
               </a:rPr>
-              <a:t>•  Plus comiesięczny dzień z wolnym wstępem dla wszystkich.</a:t>
-            </a:r>
-          </a:p>
-        </p:txBody>
-      </p:sp>
-      <p:sp>
-        <p:nvSpPr>
-          <p:cNvPr id="5" name="TextBox 4"/>
-          <p:cNvSpPr txBox="1"/>
-          <p:nvPr/>
-        </p:nvSpPr>
-        <p:spPr>
-          <a:xfrm>
-            <a:off x="822960" y="5394960"/>
-            <a:ext cx="10515600" cy="1005840"/>
-          </a:xfrm>
-          <a:prstGeom prst="rect">
-            <a:avLst/>
-          </a:prstGeom>
-          <a:noFill/>
-        </p:spPr>
-        <p:txBody>
-          <a:bodyPr wrap="square">
-            <a:spAutoFit/>
-          </a:bodyPr>
-          <a:lstStyle/>
-          <a:p>
-            <a:pPr algn="l">
-              <a:spcAft>
-                <a:spcPts val="800"/>
-              </a:spcAft>
-            </a:pPr>
-            <a:r>
-              <a:rPr sz="1900" b="1" i="0">
-                <a:solidFill>
-                  <a:srgbClr val="C9821A"/>
-                </a:solidFill>
-                <a:latin typeface="Arial"/>
-              </a:rPr>
-              <a:t>Nie namawiamy. Nie przekonujemy. Otwieramy drzwi — i patrzymy, kto wejdzie.</a:t>
+              <a:t>•  Muzeum nie musi zgadywać, co interesuje mieszkańców — może ich po prostu zapytać.</a:t>
             </a:r>
           </a:p>
         </p:txBody>

</xml_diff>